<commit_message>
docs: Add PDF version of investor pitch for GitHub inline viewing
- Convert pptx to PDF via Keynote for GitHub preview
- Update pptx to v3.4 values (σ_eff 9.5dB, p_L ~7×10⁻⁵, $3.08M)
- README: Add clickable PDF link in navigation table

Co-Authored-By: Claude Opus 4.6 (1M context) <noreply@anthropic.com>
</commit_message>
<xml_diff>
--- a/assets/TAROS_Investor_Pitch_Revised.pptx
+++ b/assets/TAROS_Investor_Pitch_Revised.pptx
@@ -2434,6 +2434,10 @@
             <a:prstDash val="solid"/>
           </a:ln>
         </p:spPr>
+        <p:txBody>
+          <a:bodyPr/>
+          <a:p/>
+        </p:txBody>
       </p:sp>
       <p:sp>
         <p:nvSpPr>
@@ -2457,6 +2461,10 @@
             <a:prstDash val="solid"/>
           </a:ln>
         </p:spPr>
+        <p:txBody>
+          <a:bodyPr/>
+          <a:p/>
+        </p:txBody>
       </p:sp>
       <p:sp>
         <p:nvSpPr>
@@ -2480,6 +2488,10 @@
             <a:prstDash val="solid"/>
           </a:ln>
         </p:spPr>
+        <p:txBody>
+          <a:bodyPr/>
+          <a:p/>
+        </p:txBody>
       </p:sp>
       <p:sp>
         <p:nvSpPr>
@@ -2503,6 +2515,10 @@
             <a:prstDash val="solid"/>
           </a:ln>
         </p:spPr>
+        <p:txBody>
+          <a:bodyPr/>
+          <a:p/>
+        </p:txBody>
       </p:sp>
       <p:sp>
         <p:nvSpPr>
@@ -2526,6 +2542,10 @@
             <a:prstDash val="solid"/>
           </a:ln>
         </p:spPr>
+        <p:txBody>
+          <a:bodyPr/>
+          <a:p/>
+        </p:txBody>
       </p:sp>
       <p:sp>
         <p:nvSpPr>
@@ -2546,6 +2566,10 @@
           </a:solidFill>
           <a:ln/>
         </p:spPr>
+        <p:txBody>
+          <a:bodyPr/>
+          <a:p/>
+        </p:txBody>
       </p:sp>
       <p:sp>
         <p:nvSpPr>
@@ -2831,7 +2855,7 @@
                 <a:ea typeface="Arial" pitchFamily="34" charset="-122"/>
                 <a:cs typeface="Arial" pitchFamily="34" charset="-120"/>
               </a:rPr>
-              <a:t>Confidential  ·  v3.2</a:t>
+              <a:t>Confidential  ·  v3.4</a:t>
             </a:r>
             <a:endParaRPr lang="en-US" sz="1100" dirty="0"/>
           </a:p>
@@ -2927,6 +2951,10 @@
           </a:solidFill>
           <a:ln/>
         </p:spPr>
+        <p:txBody>
+          <a:bodyPr/>
+          <a:p/>
+        </p:txBody>
       </p:sp>
       <p:sp>
         <p:nvSpPr>
@@ -3069,6 +3097,10 @@
             <a:prstDash val="solid"/>
           </a:ln>
         </p:spPr>
+        <p:txBody>
+          <a:bodyPr/>
+          <a:p/>
+        </p:txBody>
       </p:sp>
       <p:sp>
         <p:nvSpPr>
@@ -3170,6 +3202,10 @@
             <a:prstDash val="solid"/>
           </a:ln>
         </p:spPr>
+        <p:txBody>
+          <a:bodyPr/>
+          <a:p/>
+        </p:txBody>
       </p:sp>
       <p:sp>
         <p:nvSpPr>
@@ -3273,6 +3309,10 @@
             <a:prstDash val="solid"/>
           </a:ln>
         </p:spPr>
+        <p:txBody>
+          <a:bodyPr/>
+          <a:p/>
+        </p:txBody>
       </p:sp>
       <p:sp>
         <p:nvSpPr>
@@ -3374,6 +3414,10 @@
             <a:prstDash val="solid"/>
           </a:ln>
         </p:spPr>
+        <p:txBody>
+          <a:bodyPr/>
+          <a:p/>
+        </p:txBody>
       </p:sp>
       <p:sp>
         <p:nvSpPr>
@@ -3477,6 +3521,10 @@
             <a:prstDash val="solid"/>
           </a:ln>
         </p:spPr>
+        <p:txBody>
+          <a:bodyPr/>
+          <a:p/>
+        </p:txBody>
       </p:sp>
       <p:sp>
         <p:nvSpPr>
@@ -3578,6 +3626,10 @@
             <a:prstDash val="solid"/>
           </a:ln>
         </p:spPr>
+        <p:txBody>
+          <a:bodyPr/>
+          <a:p/>
+        </p:txBody>
       </p:sp>
       <p:sp>
         <p:nvSpPr>
@@ -3681,6 +3733,10 @@
             <a:prstDash val="solid"/>
           </a:ln>
         </p:spPr>
+        <p:txBody>
+          <a:bodyPr/>
+          <a:p/>
+        </p:txBody>
       </p:sp>
       <p:sp>
         <p:nvSpPr>
@@ -3782,6 +3838,10 @@
             <a:prstDash val="solid"/>
           </a:ln>
         </p:spPr>
+        <p:txBody>
+          <a:bodyPr/>
+          <a:p/>
+        </p:txBody>
       </p:sp>
       <p:sp>
         <p:nvSpPr>
@@ -3990,6 +4050,10 @@
           </a:solidFill>
           <a:ln/>
         </p:spPr>
+        <p:txBody>
+          <a:bodyPr/>
+          <a:p/>
+        </p:txBody>
       </p:sp>
       <p:sp>
         <p:nvSpPr>
@@ -4166,6 +4230,10 @@
           </a:solidFill>
           <a:ln/>
         </p:spPr>
+        <p:txBody>
+          <a:bodyPr/>
+          <a:p/>
+        </p:txBody>
       </p:sp>
       <p:sp>
         <p:nvSpPr>
@@ -4381,6 +4449,10 @@
           </a:solidFill>
           <a:ln/>
         </p:spPr>
+        <p:txBody>
+          <a:bodyPr/>
+          <a:p/>
+        </p:txBody>
       </p:sp>
       <p:sp>
         <p:nvSpPr>
@@ -4596,6 +4668,10 @@
           </a:solidFill>
           <a:ln/>
         </p:spPr>
+        <p:txBody>
+          <a:bodyPr/>
+          <a:p/>
+        </p:txBody>
       </p:sp>
       <p:sp>
         <p:nvSpPr>
@@ -4811,6 +4887,10 @@
           </a:solidFill>
           <a:ln/>
         </p:spPr>
+        <p:txBody>
+          <a:bodyPr/>
+          <a:p/>
+        </p:txBody>
       </p:sp>
       <p:sp>
         <p:nvSpPr>
@@ -4987,6 +5067,10 @@
           </a:solidFill>
           <a:ln/>
         </p:spPr>
+        <p:txBody>
+          <a:bodyPr/>
+          <a:p/>
+        </p:txBody>
       </p:sp>
       <p:sp>
         <p:nvSpPr>
@@ -5085,6 +5169,10 @@
           </a:solidFill>
           <a:ln/>
         </p:spPr>
+        <p:txBody>
+          <a:bodyPr/>
+          <a:p/>
+        </p:txBody>
       </p:sp>
       <p:sp>
         <p:nvSpPr>
@@ -5183,6 +5271,10 @@
           </a:solidFill>
           <a:ln/>
         </p:spPr>
+        <p:txBody>
+          <a:bodyPr/>
+          <a:p/>
+        </p:txBody>
       </p:sp>
       <p:sp>
         <p:nvSpPr>
@@ -5281,6 +5373,10 @@
           </a:solidFill>
           <a:ln/>
         </p:spPr>
+        <p:txBody>
+          <a:bodyPr/>
+          <a:p/>
+        </p:txBody>
       </p:sp>
       <p:sp>
         <p:nvSpPr>
@@ -5379,6 +5475,10 @@
           </a:solidFill>
           <a:ln/>
         </p:spPr>
+        <p:txBody>
+          <a:bodyPr/>
+          <a:p/>
+        </p:txBody>
       </p:sp>
       <p:sp>
         <p:nvSpPr>
@@ -5438,6 +5538,10 @@
           </a:solidFill>
           <a:ln/>
         </p:spPr>
+        <p:txBody>
+          <a:bodyPr/>
+          <a:p/>
+        </p:txBody>
       </p:sp>
       <p:sp>
         <p:nvSpPr>
@@ -5458,6 +5562,10 @@
           </a:solidFill>
           <a:ln/>
         </p:spPr>
+        <p:txBody>
+          <a:bodyPr/>
+          <a:p/>
+        </p:txBody>
       </p:sp>
       <p:sp>
         <p:nvSpPr>
@@ -5900,6 +6008,10 @@
           </a:solidFill>
           <a:ln/>
         </p:spPr>
+        <p:txBody>
+          <a:bodyPr/>
+          <a:p/>
+        </p:txBody>
       </p:sp>
       <p:sp>
         <p:nvSpPr>
@@ -6053,6 +6165,10 @@
           </a:solidFill>
           <a:ln/>
         </p:spPr>
+        <p:txBody>
+          <a:bodyPr/>
+          <a:p/>
+        </p:txBody>
       </p:sp>
       <p:sp>
         <p:nvSpPr>
@@ -6073,6 +6189,10 @@
           </a:solidFill>
           <a:ln/>
         </p:spPr>
+        <p:txBody>
+          <a:bodyPr/>
+          <a:p/>
+        </p:txBody>
       </p:sp>
       <p:sp>
         <p:nvSpPr>
@@ -6210,6 +6330,10 @@
           </a:solidFill>
           <a:ln/>
         </p:spPr>
+        <p:txBody>
+          <a:bodyPr/>
+          <a:p/>
+        </p:txBody>
       </p:sp>
       <p:sp>
         <p:nvSpPr>
@@ -6230,6 +6354,10 @@
           </a:solidFill>
           <a:ln/>
         </p:spPr>
+        <p:txBody>
+          <a:bodyPr/>
+          <a:p/>
+        </p:txBody>
       </p:sp>
       <p:sp>
         <p:nvSpPr>
@@ -6367,6 +6495,10 @@
           </a:solidFill>
           <a:ln/>
         </p:spPr>
+        <p:txBody>
+          <a:bodyPr/>
+          <a:p/>
+        </p:txBody>
       </p:sp>
       <p:sp>
         <p:nvSpPr>
@@ -6387,6 +6519,10 @@
           </a:solidFill>
           <a:ln/>
         </p:spPr>
+        <p:txBody>
+          <a:bodyPr/>
+          <a:p/>
+        </p:txBody>
       </p:sp>
       <p:sp>
         <p:nvSpPr>
@@ -6524,6 +6660,10 @@
           </a:solidFill>
           <a:ln/>
         </p:spPr>
+        <p:txBody>
+          <a:bodyPr/>
+          <a:p/>
+        </p:txBody>
       </p:sp>
       <p:sp>
         <p:nvSpPr>
@@ -6544,6 +6684,10 @@
           </a:solidFill>
           <a:ln/>
         </p:spPr>
+        <p:txBody>
+          <a:bodyPr/>
+          <a:p/>
+        </p:txBody>
       </p:sp>
       <p:sp>
         <p:nvSpPr>
@@ -6681,6 +6825,10 @@
           </a:solidFill>
           <a:ln/>
         </p:spPr>
+        <p:txBody>
+          <a:bodyPr/>
+          <a:p/>
+        </p:txBody>
       </p:sp>
       <p:sp>
         <p:nvSpPr>
@@ -6878,6 +7026,10 @@
           </a:solidFill>
           <a:ln/>
         </p:spPr>
+        <p:txBody>
+          <a:bodyPr/>
+          <a:p/>
+        </p:txBody>
       </p:sp>
       <p:sp>
         <p:nvSpPr>
@@ -7029,7 +7181,7 @@
                 <a:ea typeface="Arial" pitchFamily="34" charset="-122"/>
                 <a:cs typeface="Arial" pitchFamily="34" charset="-120"/>
               </a:rPr>
-              <a:t>※ 為替前提: 1USD = 150円 で換算 ($3.04M)</a:t>
+              <a:t>※ 為替前提: 1USD = 150円 で換算 ($3.08M)</a:t>
             </a:r>
             <a:endParaRPr lang="en-US" sz="1000" dirty="0"/>
           </a:p>
@@ -7054,6 +7206,10 @@
           </a:solidFill>
           <a:ln/>
         </p:spPr>
+        <p:txBody>
+          <a:bodyPr/>
+          <a:p/>
+        </p:txBody>
       </p:sp>
       <p:sp>
         <p:nvSpPr>
@@ -7074,6 +7230,10 @@
           </a:solidFill>
           <a:ln/>
         </p:spPr>
+        <p:txBody>
+          <a:bodyPr/>
+          <a:p/>
+        </p:txBody>
       </p:sp>
       <p:sp>
         <p:nvSpPr>
@@ -7214,6 +7374,10 @@
             <a:prstDash val="solid"/>
           </a:ln>
         </p:spPr>
+        <p:txBody>
+          <a:bodyPr/>
+          <a:p/>
+        </p:txBody>
       </p:sp>
       <p:sp>
         <p:nvSpPr>
@@ -7390,6 +7554,10 @@
           </a:solidFill>
           <a:ln/>
         </p:spPr>
+        <p:txBody>
+          <a:bodyPr/>
+          <a:p/>
+        </p:txBody>
       </p:sp>
       <p:sp>
         <p:nvSpPr>
@@ -7527,6 +7695,10 @@
           </a:solidFill>
           <a:ln/>
         </p:spPr>
+        <p:txBody>
+          <a:bodyPr/>
+          <a:p/>
+        </p:txBody>
       </p:sp>
       <p:sp>
         <p:nvSpPr>
@@ -7664,6 +7836,10 @@
           </a:solidFill>
           <a:ln/>
         </p:spPr>
+        <p:txBody>
+          <a:bodyPr/>
+          <a:p/>
+        </p:txBody>
       </p:sp>
       <p:sp>
         <p:nvSpPr>
@@ -7836,6 +8012,10 @@
             <a:prstDash val="solid"/>
           </a:ln>
         </p:spPr>
+        <p:txBody>
+          <a:bodyPr/>
+          <a:p/>
+        </p:txBody>
       </p:sp>
       <p:sp>
         <p:nvSpPr>
@@ -7859,6 +8039,10 @@
             <a:prstDash val="solid"/>
           </a:ln>
         </p:spPr>
+        <p:txBody>
+          <a:bodyPr/>
+          <a:p/>
+        </p:txBody>
       </p:sp>
       <p:sp>
         <p:nvSpPr>
@@ -7882,6 +8066,10 @@
             <a:prstDash val="solid"/>
           </a:ln>
         </p:spPr>
+        <p:txBody>
+          <a:bodyPr/>
+          <a:p/>
+        </p:txBody>
       </p:sp>
       <p:sp>
         <p:nvSpPr>
@@ -7905,6 +8093,10 @@
             <a:prstDash val="solid"/>
           </a:ln>
         </p:spPr>
+        <p:txBody>
+          <a:bodyPr/>
+          <a:p/>
+        </p:txBody>
       </p:sp>
       <p:sp>
         <p:nvSpPr>
@@ -7928,6 +8120,10 @@
             <a:prstDash val="solid"/>
           </a:ln>
         </p:spPr>
+        <p:txBody>
+          <a:bodyPr/>
+          <a:p/>
+        </p:txBody>
       </p:sp>
       <p:sp>
         <p:nvSpPr>
@@ -8065,6 +8261,10 @@
           </a:solidFill>
           <a:ln/>
         </p:spPr>
+        <p:txBody>
+          <a:bodyPr/>
+          <a:p/>
+        </p:txBody>
       </p:sp>
       <p:sp>
         <p:nvSpPr>
@@ -8166,6 +8366,10 @@
             <a:prstDash val="solid"/>
           </a:ln>
         </p:spPr>
+        <p:txBody>
+          <a:bodyPr/>
+          <a:p/>
+        </p:txBody>
       </p:sp>
       <p:sp>
         <p:nvSpPr>
@@ -8200,7 +8404,7 @@
                 <a:ea typeface="Arial" pitchFamily="34" charset="-122"/>
                 <a:cs typeface="Arial" pitchFamily="34" charset="-120"/>
               </a:rPr>
-              <a:t>TAROS  ·  Tabletop · Room-temperature · Optical · System  ·  May 2026  ·  v3.2</a:t>
+              <a:t>TAROS  ·  Tabletop · Room-temperature · Optical · System  ·  May 2026  ·  v3.4</a:t>
             </a:r>
             <a:endParaRPr lang="en-US" sz="1100" dirty="0"/>
           </a:p>
@@ -8296,6 +8500,10 @@
           </a:solidFill>
           <a:ln/>
         </p:spPr>
+        <p:txBody>
+          <a:bodyPr/>
+          <a:p/>
+        </p:txBody>
       </p:sp>
       <p:sp>
         <p:nvSpPr>
@@ -8445,6 +8653,10 @@
             </a:outerShdw>
           </a:effectLst>
         </p:spPr>
+        <p:txBody>
+          <a:bodyPr/>
+          <a:p/>
+        </p:txBody>
       </p:sp>
       <p:sp>
         <p:nvSpPr>
@@ -8465,6 +8677,10 @@
           </a:solidFill>
           <a:ln/>
         </p:spPr>
+        <p:txBody>
+          <a:bodyPr/>
+          <a:p/>
+        </p:txBody>
       </p:sp>
       <p:pic>
         <p:nvPicPr>
@@ -8599,6 +8815,10 @@
             </a:outerShdw>
           </a:effectLst>
         </p:spPr>
+        <p:txBody>
+          <a:bodyPr/>
+          <a:p/>
+        </p:txBody>
       </p:sp>
       <p:sp>
         <p:nvSpPr>
@@ -8619,6 +8839,10 @@
           </a:solidFill>
           <a:ln/>
         </p:spPr>
+        <p:txBody>
+          <a:bodyPr/>
+          <a:p/>
+        </p:txBody>
       </p:sp>
       <p:pic>
         <p:nvPicPr>
@@ -8753,6 +8977,10 @@
             </a:outerShdw>
           </a:effectLst>
         </p:spPr>
+        <p:txBody>
+          <a:bodyPr/>
+          <a:p/>
+        </p:txBody>
       </p:sp>
       <p:sp>
         <p:nvSpPr>
@@ -8773,6 +9001,10 @@
           </a:solidFill>
           <a:ln/>
         </p:spPr>
+        <p:txBody>
+          <a:bodyPr/>
+          <a:p/>
+        </p:txBody>
       </p:sp>
       <p:pic>
         <p:nvPicPr>
@@ -8870,7 +9102,7 @@
                 <a:ea typeface="Arial" pitchFamily="34" charset="-122"/>
                 <a:cs typeface="Arial" pitchFamily="34" charset="-120"/>
               </a:rPr>
-              <a:t>p_L &lt; 10⁻⁵ (d=7, MWPM, 製品要件)。Phase 2+ PIC 統合で論理エラー率を物理エラー率以下へ。</a:t>
+              <a:t>p_L ≲ 10⁻⁴ (d=7, MWPM, 製品要件)。Phase 2+ PIC 統合で論理エラー率を物理エラー率以下へ。</a:t>
             </a:r>
             <a:endParaRPr lang="en-US" sz="1300" dirty="0"/>
           </a:p>
@@ -8966,6 +9198,10 @@
           </a:solidFill>
           <a:ln/>
         </p:spPr>
+        <p:txBody>
+          <a:bodyPr/>
+          <a:p/>
+        </p:txBody>
       </p:sp>
       <p:sp>
         <p:nvSpPr>
@@ -9142,6 +9378,10 @@
           </a:solidFill>
           <a:ln/>
         </p:spPr>
+        <p:txBody>
+          <a:bodyPr/>
+          <a:p/>
+        </p:txBody>
       </p:sp>
       <p:sp>
         <p:nvSpPr>
@@ -9162,6 +9402,10 @@
           </a:solidFill>
           <a:ln/>
         </p:spPr>
+        <p:txBody>
+          <a:bodyPr/>
+          <a:p/>
+        </p:txBody>
       </p:sp>
       <p:sp>
         <p:nvSpPr>
@@ -9299,6 +9543,10 @@
           </a:solidFill>
           <a:ln/>
         </p:spPr>
+        <p:txBody>
+          <a:bodyPr/>
+          <a:p/>
+        </p:txBody>
       </p:sp>
       <p:sp>
         <p:nvSpPr>
@@ -9319,6 +9567,10 @@
           </a:solidFill>
           <a:ln/>
         </p:spPr>
+        <p:txBody>
+          <a:bodyPr/>
+          <a:p/>
+        </p:txBody>
       </p:sp>
       <p:sp>
         <p:nvSpPr>
@@ -9456,6 +9708,10 @@
           </a:solidFill>
           <a:ln/>
         </p:spPr>
+        <p:txBody>
+          <a:bodyPr/>
+          <a:p/>
+        </p:txBody>
       </p:sp>
       <p:sp>
         <p:nvSpPr>
@@ -9476,6 +9732,10 @@
           </a:solidFill>
           <a:ln/>
         </p:spPr>
+        <p:txBody>
+          <a:bodyPr/>
+          <a:p/>
+        </p:txBody>
       </p:sp>
       <p:sp>
         <p:nvSpPr>
@@ -9613,6 +9873,10 @@
           </a:solidFill>
           <a:ln/>
         </p:spPr>
+        <p:txBody>
+          <a:bodyPr/>
+          <a:p/>
+        </p:txBody>
       </p:sp>
       <p:sp>
         <p:nvSpPr>
@@ -9633,6 +9897,10 @@
           </a:solidFill>
           <a:ln/>
         </p:spPr>
+        <p:txBody>
+          <a:bodyPr/>
+          <a:p/>
+        </p:txBody>
       </p:sp>
       <p:sp>
         <p:nvSpPr>
@@ -9880,6 +10148,10 @@
           </a:solidFill>
           <a:ln/>
         </p:spPr>
+        <p:txBody>
+          <a:bodyPr/>
+          <a:p/>
+        </p:txBody>
       </p:sp>
       <p:sp>
         <p:nvSpPr>
@@ -10017,6 +10289,10 @@
           </a:solidFill>
           <a:ln/>
         </p:spPr>
+        <p:txBody>
+          <a:bodyPr/>
+          <a:p/>
+        </p:txBody>
       </p:sp>
       <p:sp>
         <p:nvSpPr>
@@ -10154,6 +10430,10 @@
           </a:solidFill>
           <a:ln/>
         </p:spPr>
+        <p:txBody>
+          <a:bodyPr/>
+          <a:p/>
+        </p:txBody>
       </p:sp>
       <p:sp>
         <p:nvSpPr>
@@ -10291,6 +10571,10 @@
           </a:solidFill>
           <a:ln/>
         </p:spPr>
+        <p:txBody>
+          <a:bodyPr/>
+          <a:p/>
+        </p:txBody>
       </p:sp>
       <p:sp>
         <p:nvSpPr>
@@ -10428,6 +10712,10 @@
           </a:solidFill>
           <a:ln/>
         </p:spPr>
+        <p:txBody>
+          <a:bodyPr/>
+          <a:p/>
+        </p:txBody>
       </p:sp>
       <p:sp>
         <p:nvSpPr>
@@ -10604,6 +10892,10 @@
           </a:solidFill>
           <a:ln/>
         </p:spPr>
+        <p:txBody>
+          <a:bodyPr/>
+          <a:p/>
+        </p:txBody>
       </p:sp>
       <p:sp>
         <p:nvSpPr>
@@ -10702,6 +10994,10 @@
           </a:solidFill>
           <a:ln/>
         </p:spPr>
+        <p:txBody>
+          <a:bodyPr/>
+          <a:p/>
+        </p:txBody>
       </p:sp>
       <p:sp>
         <p:nvSpPr>
@@ -10800,6 +11096,10 @@
           </a:solidFill>
           <a:ln/>
         </p:spPr>
+        <p:txBody>
+          <a:bodyPr/>
+          <a:p/>
+        </p:txBody>
       </p:sp>
       <p:sp>
         <p:nvSpPr>
@@ -10937,6 +11237,10 @@
           </a:solidFill>
           <a:ln/>
         </p:spPr>
+        <p:txBody>
+          <a:bodyPr/>
+          <a:p/>
+        </p:txBody>
       </p:sp>
       <p:sp>
         <p:nvSpPr>
@@ -11035,6 +11339,10 @@
           </a:solidFill>
           <a:ln/>
         </p:spPr>
+        <p:txBody>
+          <a:bodyPr/>
+          <a:p/>
+        </p:txBody>
       </p:sp>
       <p:sp>
         <p:nvSpPr>
@@ -11133,6 +11441,10 @@
           </a:solidFill>
           <a:ln/>
         </p:spPr>
+        <p:txBody>
+          <a:bodyPr/>
+          <a:p/>
+        </p:txBody>
       </p:sp>
       <p:sp>
         <p:nvSpPr>
@@ -11302,6 +11614,10 @@
           </a:solidFill>
           <a:ln/>
         </p:spPr>
+        <p:txBody>
+          <a:bodyPr/>
+          <a:p/>
+        </p:txBody>
       </p:sp>
       <p:sp>
         <p:nvSpPr>
@@ -11439,6 +11755,10 @@
           </a:solidFill>
           <a:ln/>
         </p:spPr>
+        <p:txBody>
+          <a:bodyPr/>
+          <a:p/>
+        </p:txBody>
       </p:sp>
       <p:sp>
         <p:nvSpPr>
@@ -11615,6 +11935,10 @@
           </a:solidFill>
           <a:ln/>
         </p:spPr>
+        <p:txBody>
+          <a:bodyPr/>
+          <a:p/>
+        </p:txBody>
       </p:sp>
       <p:sp>
         <p:nvSpPr>
@@ -11791,6 +12115,10 @@
           </a:solidFill>
           <a:ln/>
         </p:spPr>
+        <p:txBody>
+          <a:bodyPr/>
+          <a:p/>
+        </p:txBody>
       </p:sp>
       <p:sp>
         <p:nvSpPr>
@@ -11825,7 +12153,7 @@
                 <a:ea typeface="Arial" pitchFamily="34" charset="-122"/>
                 <a:cs typeface="Arial" pitchFamily="34" charset="-120"/>
               </a:rPr>
-              <a:t>9.7dB</a:t>
+              <a:t>9.5dB</a:t>
             </a:r>
             <a:endParaRPr lang="en-US" sz="2400" dirty="0"/>
           </a:p>
@@ -11967,6 +12295,10 @@
           </a:solidFill>
           <a:ln/>
         </p:spPr>
+        <p:txBody>
+          <a:bodyPr/>
+          <a:p/>
+        </p:txBody>
       </p:sp>
       <p:sp>
         <p:nvSpPr>
@@ -12143,6 +12475,10 @@
           </a:solidFill>
           <a:ln/>
         </p:spPr>
+        <p:txBody>
+          <a:bodyPr/>
+          <a:p/>
+        </p:txBody>
       </p:sp>
       <p:sp>
         <p:nvSpPr>
@@ -12177,7 +12513,7 @@
                 <a:ea typeface="Arial" pitchFamily="34" charset="-122"/>
                 <a:cs typeface="Arial" pitchFamily="34" charset="-120"/>
               </a:rPr>
-              <a:t>&lt;10⁻⁵</a:t>
+              <a:t>~7×10⁻⁵</a:t>
             </a:r>
             <a:endParaRPr lang="en-US" sz="2400" dirty="0"/>
           </a:p>
@@ -12280,6 +12616,10 @@
           </a:solidFill>
           <a:ln/>
         </p:spPr>
+        <p:txBody>
+          <a:bodyPr/>
+          <a:p/>
+        </p:txBody>
       </p:sp>
       <p:pic>
         <p:nvPicPr>
@@ -12402,6 +12742,10 @@
           </a:solidFill>
           <a:ln/>
         </p:spPr>
+        <p:txBody>
+          <a:bodyPr/>
+          <a:p/>
+        </p:txBody>
       </p:sp>
       <p:sp>
         <p:nvSpPr>
@@ -12422,6 +12766,10 @@
           </a:solidFill>
           <a:ln/>
         </p:spPr>
+        <p:txBody>
+          <a:bodyPr/>
+          <a:p/>
+        </p:txBody>
       </p:sp>
       <p:sp>
         <p:nvSpPr>
@@ -12456,7 +12804,7 @@
                 <a:ea typeface="Arial" pitchFamily="34" charset="-122"/>
                 <a:cs typeface="Arial" pitchFamily="34" charset="-120"/>
               </a:rPr>
-              <a:t>9.7 dB</a:t>
+              <a:t>9.5 dB</a:t>
             </a:r>
             <a:endParaRPr lang="en-US" sz="1100" dirty="0"/>
           </a:p>
@@ -12520,6 +12868,10 @@
           </a:solidFill>
           <a:ln/>
         </p:spPr>
+        <p:txBody>
+          <a:bodyPr/>
+          <a:p/>
+        </p:txBody>
       </p:sp>
       <p:sp>
         <p:nvSpPr>
@@ -12540,6 +12892,10 @@
           </a:solidFill>
           <a:ln/>
         </p:spPr>
+        <p:txBody>
+          <a:bodyPr/>
+          <a:p/>
+        </p:txBody>
       </p:sp>
       <p:sp>
         <p:nvSpPr>
@@ -12638,6 +12994,10 @@
           </a:solidFill>
           <a:ln/>
         </p:spPr>
+        <p:txBody>
+          <a:bodyPr/>
+          <a:p/>
+        </p:txBody>
       </p:sp>
       <p:sp>
         <p:nvSpPr>
@@ -12658,6 +13018,10 @@
           </a:solidFill>
           <a:ln/>
         </p:spPr>
+        <p:txBody>
+          <a:bodyPr/>
+          <a:p/>
+        </p:txBody>
       </p:sp>
       <p:sp>
         <p:nvSpPr>
@@ -12731,7 +13095,7 @@
                 <a:ea typeface="Arial" pitchFamily="34" charset="-122"/>
                 <a:cs typeface="Arial" pitchFamily="34" charset="-120"/>
               </a:rPr>
-              <a:t>→ Phase 2+ PIC 余裕 +3.4dB (PS) / +0.9dB (全モード) — 製品要件 p_L &lt; 10⁻⁵ を達成</a:t>
+              <a:t>→ Phase 2+ PIC 余裕 +3.4dB (PS) / +0.9dB (全モード) — 製品要件 p_L ≲ 10⁻⁴ を達成</a:t>
             </a:r>
             <a:endParaRPr lang="en-US" sz="1200" dirty="0"/>
           </a:p>
@@ -12827,6 +13191,10 @@
           </a:solidFill>
           <a:ln/>
         </p:spPr>
+        <p:txBody>
+          <a:bodyPr/>
+          <a:p/>
+        </p:txBody>
       </p:sp>
       <p:sp>
         <p:nvSpPr>
@@ -12964,6 +13332,10 @@
           </a:solidFill>
           <a:ln/>
         </p:spPr>
+        <p:txBody>
+          <a:bodyPr/>
+          <a:p/>
+        </p:txBody>
       </p:sp>
       <p:sp>
         <p:nvSpPr>
@@ -12989,6 +13361,10 @@
             <a:prstDash val="solid"/>
           </a:ln>
         </p:spPr>
+        <p:txBody>
+          <a:bodyPr/>
+          <a:p/>
+        </p:txBody>
       </p:sp>
       <p:sp>
         <p:nvSpPr>
@@ -13441,6 +13817,10 @@
             <a:prstDash val="solid"/>
           </a:ln>
         </p:spPr>
+        <p:txBody>
+          <a:bodyPr/>
+          <a:p/>
+        </p:txBody>
       </p:sp>
       <p:pic>
         <p:nvPicPr>
@@ -13524,6 +13904,10 @@
           </a:solidFill>
           <a:ln/>
         </p:spPr>
+        <p:txBody>
+          <a:bodyPr/>
+          <a:p/>
+        </p:txBody>
       </p:sp>
       <p:sp>
         <p:nvSpPr>
@@ -13549,6 +13933,10 @@
             <a:prstDash val="solid"/>
           </a:ln>
         </p:spPr>
+        <p:txBody>
+          <a:bodyPr/>
+          <a:p/>
+        </p:txBody>
       </p:sp>
       <p:sp>
         <p:nvSpPr>
@@ -13569,6 +13957,10 @@
           </a:solidFill>
           <a:ln/>
         </p:spPr>
+        <p:txBody>
+          <a:bodyPr/>
+          <a:p/>
+        </p:txBody>
       </p:sp>
       <p:sp>
         <p:nvSpPr>
@@ -14060,6 +14452,10 @@
             <a:prstDash val="solid"/>
           </a:ln>
         </p:spPr>
+        <p:txBody>
+          <a:bodyPr/>
+          <a:p/>
+        </p:txBody>
       </p:sp>
       <p:pic>
         <p:nvPicPr>
@@ -14143,6 +14539,10 @@
           </a:solidFill>
           <a:ln/>
         </p:spPr>
+        <p:txBody>
+          <a:bodyPr/>
+          <a:p/>
+        </p:txBody>
       </p:sp>
       <p:sp>
         <p:nvSpPr>
@@ -14168,6 +14568,10 @@
             <a:prstDash val="solid"/>
           </a:ln>
         </p:spPr>
+        <p:txBody>
+          <a:bodyPr/>
+          <a:p/>
+        </p:txBody>
       </p:sp>
       <p:sp>
         <p:nvSpPr>
@@ -14620,6 +15024,10 @@
             <a:prstDash val="solid"/>
           </a:ln>
         </p:spPr>
+        <p:txBody>
+          <a:bodyPr/>
+          <a:p/>
+        </p:txBody>
       </p:sp>
       <p:pic>
         <p:nvPicPr>
@@ -14756,7 +15164,7 @@
                 <a:ea typeface="Arial" pitchFamily="34" charset="-122"/>
                 <a:cs typeface="Arial" pitchFamily="34" charset="-120"/>
               </a:rPr>
-              <a:t>† Max の p_L=5.7×10⁻⁷ は Phase 2+ PIC 全条件達成時の理論上限値。製品スペックは p_L &lt; 10⁻⁵ (MWPM, d=7)。</a:t>
+              <a:t>† Max の p_L=5.7×10⁻⁷ は Phase 2+ PIC 全条件達成時の理論上限値。製品スペックは p_L ~7×10⁻⁵ (MWPM, d=7, L=0.27dB)。</a:t>
             </a:r>
             <a:endParaRPr lang="en-US" sz="900" dirty="0"/>
           </a:p>
@@ -14852,6 +15260,10 @@
           </a:solidFill>
           <a:ln/>
         </p:spPr>
+        <p:txBody>
+          <a:bodyPr/>
+          <a:p/>
+        </p:txBody>
       </p:sp>
       <p:sp>
         <p:nvSpPr>
@@ -17390,6 +17802,10 @@
           </a:solidFill>
           <a:ln/>
         </p:spPr>
+        <p:txBody>
+          <a:bodyPr/>
+          <a:p/>
+        </p:txBody>
       </p:sp>
       <p:sp>
         <p:nvSpPr>
@@ -17527,6 +17943,10 @@
           </a:solidFill>
           <a:ln/>
         </p:spPr>
+        <p:txBody>
+          <a:bodyPr/>
+          <a:p/>
+        </p:txBody>
       </p:sp>
       <p:sp>
         <p:nvSpPr>
@@ -17664,6 +18084,10 @@
           </a:solidFill>
           <a:ln/>
         </p:spPr>
+        <p:txBody>
+          <a:bodyPr/>
+          <a:p/>
+        </p:txBody>
       </p:sp>
       <p:sp>
         <p:nvSpPr>
@@ -17872,6 +18296,10 @@
           </a:solidFill>
           <a:ln/>
         </p:spPr>
+        <p:txBody>
+          <a:bodyPr/>
+          <a:p/>
+        </p:txBody>
       </p:sp>
       <p:sp>
         <p:nvSpPr>
@@ -18012,6 +18440,10 @@
             <a:prstDash val="dash"/>
           </a:ln>
         </p:spPr>
+        <p:txBody>
+          <a:bodyPr/>
+          <a:p/>
+        </p:txBody>
       </p:sp>
       <p:sp>
         <p:nvSpPr>
@@ -18037,6 +18469,10 @@
             <a:prstDash val="solid"/>
           </a:ln>
         </p:spPr>
+        <p:txBody>
+          <a:bodyPr/>
+          <a:p/>
+        </p:txBody>
       </p:sp>
       <p:sp>
         <p:nvSpPr>
@@ -18257,6 +18693,10 @@
             <a:prstDash val="solid"/>
           </a:ln>
         </p:spPr>
+        <p:txBody>
+          <a:bodyPr/>
+          <a:p/>
+        </p:txBody>
       </p:sp>
       <p:sp>
         <p:nvSpPr>
@@ -18477,6 +18917,10 @@
             <a:prstDash val="solid"/>
           </a:ln>
         </p:spPr>
+        <p:txBody>
+          <a:bodyPr/>
+          <a:p/>
+        </p:txBody>
       </p:sp>
       <p:sp>
         <p:nvSpPr>
@@ -18697,6 +19141,10 @@
             <a:prstDash val="solid"/>
           </a:ln>
         </p:spPr>
+        <p:txBody>
+          <a:bodyPr/>
+          <a:p/>
+        </p:txBody>
       </p:sp>
       <p:sp>
         <p:nvSpPr>
@@ -18912,6 +19360,10 @@
           </a:solidFill>
           <a:ln/>
         </p:spPr>
+        <p:txBody>
+          <a:bodyPr/>
+          <a:p/>
+        </p:txBody>
       </p:sp>
       <p:sp>
         <p:nvSpPr>
@@ -18932,6 +19384,10 @@
           </a:solidFill>
           <a:ln/>
         </p:spPr>
+        <p:txBody>
+          <a:bodyPr/>
+          <a:p/>
+        </p:txBody>
       </p:sp>
       <p:sp>
         <p:nvSpPr>
@@ -19090,6 +19546,10 @@
           </a:solidFill>
           <a:ln/>
         </p:spPr>
+        <p:txBody>
+          <a:bodyPr/>
+          <a:p/>
+        </p:txBody>
       </p:sp>
       <p:sp>
         <p:nvSpPr>
@@ -19266,6 +19726,10 @@
           </a:solidFill>
           <a:ln/>
         </p:spPr>
+        <p:txBody>
+          <a:bodyPr/>
+          <a:p/>
+        </p:txBody>
       </p:sp>
       <p:sp>
         <p:nvSpPr>
@@ -19286,6 +19750,10 @@
           </a:solidFill>
           <a:ln/>
         </p:spPr>
+        <p:txBody>
+          <a:bodyPr/>
+          <a:p/>
+        </p:txBody>
       </p:sp>
       <p:sp>
         <p:nvSpPr>
@@ -19384,6 +19852,10 @@
           </a:solidFill>
           <a:ln/>
         </p:spPr>
+        <p:txBody>
+          <a:bodyPr/>
+          <a:p/>
+        </p:txBody>
       </p:sp>
       <p:sp>
         <p:nvSpPr>
@@ -19404,6 +19876,10 @@
           </a:solidFill>
           <a:ln/>
         </p:spPr>
+        <p:txBody>
+          <a:bodyPr/>
+          <a:p/>
+        </p:txBody>
       </p:sp>
       <p:sp>
         <p:nvSpPr>
@@ -19477,7 +19953,7 @@
                 <a:ea typeface="Arial" pitchFamily="34" charset="-122"/>
                 <a:cs typeface="Arial" pitchFamily="34" charset="-120"/>
               </a:rPr>
-              <a:t>Phase 0/1 は UF 350ns で実証 → Phase 2+ PIC で MWPM 510ns へ移行。製品要件 p_L&lt;10⁻⁵ には MWPM 必須。</a:t>
+              <a:t>Phase 0/1 は UF 350ns で実証 → Phase 2+ PIC で MWPM 510ns へ移行。製品要件 p_L~7×10⁻⁵ には MWPM 必須。</a:t>
             </a:r>
             <a:endParaRPr lang="en-US" sz="1100" dirty="0"/>
           </a:p>
@@ -19502,6 +19978,10 @@
           </a:solidFill>
           <a:ln/>
         </p:spPr>
+        <p:txBody>
+          <a:bodyPr/>
+          <a:p/>
+        </p:txBody>
       </p:sp>
       <p:sp>
         <p:nvSpPr>
@@ -19522,6 +20002,10 @@
           </a:solidFill>
           <a:ln/>
         </p:spPr>
+        <p:txBody>
+          <a:bodyPr/>
+          <a:p/>
+        </p:txBody>
       </p:sp>
       <p:sp>
         <p:nvSpPr>
@@ -19620,6 +20104,10 @@
           </a:solidFill>
           <a:ln/>
         </p:spPr>
+        <p:txBody>
+          <a:bodyPr/>
+          <a:p/>
+        </p:txBody>
       </p:sp>
       <p:sp>
         <p:nvSpPr>
@@ -19640,6 +20128,10 @@
           </a:solidFill>
           <a:ln/>
         </p:spPr>
+        <p:txBody>
+          <a:bodyPr/>
+          <a:p/>
+        </p:txBody>
       </p:sp>
       <p:sp>
         <p:nvSpPr>
@@ -19738,6 +20230,10 @@
           </a:solidFill>
           <a:ln/>
         </p:spPr>
+        <p:txBody>
+          <a:bodyPr/>
+          <a:p/>
+        </p:txBody>
       </p:sp>
       <p:pic>
         <p:nvPicPr>
@@ -19941,6 +20437,10 @@
             <a:prstDash val="solid"/>
           </a:ln>
         </p:spPr>
+        <p:txBody>
+          <a:bodyPr/>
+          <a:p/>
+        </p:txBody>
       </p:sp>
       <p:sp>
         <p:nvSpPr>

</xml_diff>

<commit_message>
docs: Update pitch subtitle to "Desktop Photonic Quantum Computer"
Co-Authored-By: Claude Opus 4.6 (1M context) <noreply@anthropic.com>
</commit_message>
<xml_diff>
--- a/assets/TAROS_Investor_Pitch_Revised.pptx
+++ b/assets/TAROS_Investor_Pitch_Revised.pptx
@@ -2643,7 +2643,7 @@
                 <a:ea typeface="Arial" pitchFamily="34" charset="-122"/>
                 <a:cs typeface="Arial" pitchFamily="34" charset="-120"/>
               </a:rPr>
-              <a:t>Tabletop · Room-temperature · Optical · System</a:t>
+              <a:t>Desktop Photonic Quantum Computer</a:t>
             </a:r>
             <a:endParaRPr lang="en-US" sz="1600" dirty="0"/>
           </a:p>
@@ -8404,7 +8404,7 @@
                 <a:ea typeface="Arial" pitchFamily="34" charset="-122"/>
                 <a:cs typeface="Arial" pitchFamily="34" charset="-120"/>
               </a:rPr>
-              <a:t>TAROS  ·  Tabletop · Room-temperature · Optical · System  ·  May 2026  ·  v3.4</a:t>
+              <a:t>TAROS  ·  Desktop Photonic Quantum Computer  ·  May 2026  ·  v3.4</a:t>
             </a:r>
             <a:endParaRPr lang="en-US" sz="1100" dirty="0"/>
           </a:p>

</xml_diff>

<commit_message>
docs: Fix slide 12 layout — reposition KPI cards to 2x2 grid
Co-Authored-By: Claude Opus 4.6 (1M context) <noreply@anthropic.com>
</commit_message>
<xml_diff>
--- a/assets/TAROS_Investor_Pitch_Revised.pptx
+++ b/assets/TAROS_Investor_Pitch_Revised.pptx
@@ -6137,8 +6137,8 @@
           <p:nvPr/>
         </p:nvGraphicFramePr>
         <p:xfrm>
-          <a:off x="457200" y="2103120"/>
-          <a:ext cx="6858000" cy="3657600"/>
+          <a:off x="-6766560" y="2103120"/>
+          <a:ext cx="5029200" cy="3657600"/>
         </p:xfrm>
         <a:graphic xmlns:a="http://schemas.openxmlformats.org/drawingml/2006/main">
           <a:graphicData uri="http://schemas.openxmlformats.org/drawingml/2006/chart">
@@ -6154,8 +6154,8 @@
         </p:nvSpPr>
         <p:spPr>
           <a:xfrm>
-            <a:off x="7680960" y="2103120"/>
-            <a:ext cx="4023360" cy="777240"/>
+            <a:off x="457200" y="2103120"/>
+            <a:ext cx="5029200" cy="777240"/>
           </a:xfrm>
           <a:prstGeom prst="rect">
             <a:avLst/>
@@ -6178,7 +6178,7 @@
         </p:nvSpPr>
         <p:spPr>
           <a:xfrm>
-            <a:off x="7680960" y="2103120"/>
+            <a:off x="457200" y="2103120"/>
             <a:ext cx="54864" cy="777240"/>
           </a:xfrm>
           <a:prstGeom prst="rect">
@@ -6202,8 +6202,8 @@
         </p:nvSpPr>
         <p:spPr>
           <a:xfrm>
-            <a:off x="7863840" y="2176272"/>
-            <a:ext cx="3657600" cy="256032"/>
+            <a:off x="640079" y="2176272"/>
+            <a:ext cx="5029200" cy="256032"/>
           </a:xfrm>
           <a:prstGeom prst="rect">
             <a:avLst/>
@@ -6241,8 +6241,8 @@
         </p:nvSpPr>
         <p:spPr>
           <a:xfrm>
-            <a:off x="7863840" y="2395728"/>
-            <a:ext cx="3657600" cy="329184"/>
+            <a:off x="640079" y="2395728"/>
+            <a:ext cx="5029200" cy="329184"/>
           </a:xfrm>
           <a:prstGeom prst="rect">
             <a:avLst/>
@@ -6280,8 +6280,8 @@
         </p:nvSpPr>
         <p:spPr>
           <a:xfrm>
-            <a:off x="7863840" y="2670048"/>
-            <a:ext cx="3657600" cy="256032"/>
+            <a:off x="640079" y="2670048"/>
+            <a:ext cx="5029200" cy="256032"/>
           </a:xfrm>
           <a:prstGeom prst="rect">
             <a:avLst/>
@@ -6319,8 +6319,8 @@
         </p:nvSpPr>
         <p:spPr>
           <a:xfrm>
-            <a:off x="7680960" y="2971800"/>
-            <a:ext cx="4023360" cy="777240"/>
+            <a:off x="5943600" y="2103120"/>
+            <a:ext cx="5029200" cy="777240"/>
           </a:xfrm>
           <a:prstGeom prst="rect">
             <a:avLst/>
@@ -6343,7 +6343,7 @@
         </p:nvSpPr>
         <p:spPr>
           <a:xfrm>
-            <a:off x="7680960" y="2971800"/>
+            <a:off x="5943600" y="2103120"/>
             <a:ext cx="54864" cy="777240"/>
           </a:xfrm>
           <a:prstGeom prst="rect">
@@ -6367,8 +6367,8 @@
         </p:nvSpPr>
         <p:spPr>
           <a:xfrm>
-            <a:off x="7863840" y="3044952"/>
-            <a:ext cx="3657600" cy="256032"/>
+            <a:off x="6126479" y="2176272"/>
+            <a:ext cx="5029200" cy="256032"/>
           </a:xfrm>
           <a:prstGeom prst="rect">
             <a:avLst/>
@@ -6406,8 +6406,8 @@
         </p:nvSpPr>
         <p:spPr>
           <a:xfrm>
-            <a:off x="7863840" y="3264408"/>
-            <a:ext cx="3657600" cy="329184"/>
+            <a:off x="6126479" y="2395727"/>
+            <a:ext cx="5029200" cy="329184"/>
           </a:xfrm>
           <a:prstGeom prst="rect">
             <a:avLst/>
@@ -6445,8 +6445,8 @@
         </p:nvSpPr>
         <p:spPr>
           <a:xfrm>
-            <a:off x="7863840" y="3538728"/>
-            <a:ext cx="3657600" cy="256032"/>
+            <a:off x="6126479" y="2670048"/>
+            <a:ext cx="5029200" cy="256032"/>
           </a:xfrm>
           <a:prstGeom prst="rect">
             <a:avLst/>
@@ -6484,8 +6484,8 @@
         </p:nvSpPr>
         <p:spPr>
           <a:xfrm>
-            <a:off x="7680960" y="3840480"/>
-            <a:ext cx="4023360" cy="777240"/>
+            <a:off x="457200" y="3840480"/>
+            <a:ext cx="5029200" cy="777240"/>
           </a:xfrm>
           <a:prstGeom prst="rect">
             <a:avLst/>
@@ -6508,7 +6508,7 @@
         </p:nvSpPr>
         <p:spPr>
           <a:xfrm>
-            <a:off x="7680960" y="3840480"/>
+            <a:off x="457200" y="3840480"/>
             <a:ext cx="54864" cy="777240"/>
           </a:xfrm>
           <a:prstGeom prst="rect">
@@ -6532,8 +6532,8 @@
         </p:nvSpPr>
         <p:spPr>
           <a:xfrm>
-            <a:off x="7863840" y="3913632"/>
-            <a:ext cx="3657600" cy="256032"/>
+            <a:off x="640079" y="3913632"/>
+            <a:ext cx="5029200" cy="256032"/>
           </a:xfrm>
           <a:prstGeom prst="rect">
             <a:avLst/>
@@ -6571,8 +6571,8 @@
         </p:nvSpPr>
         <p:spPr>
           <a:xfrm>
-            <a:off x="7863840" y="4133088"/>
-            <a:ext cx="3657600" cy="329184"/>
+            <a:off x="640079" y="4133087"/>
+            <a:ext cx="5029200" cy="329184"/>
           </a:xfrm>
           <a:prstGeom prst="rect">
             <a:avLst/>
@@ -6610,8 +6610,8 @@
         </p:nvSpPr>
         <p:spPr>
           <a:xfrm>
-            <a:off x="7863840" y="4407408"/>
-            <a:ext cx="3657600" cy="256032"/>
+            <a:off x="640079" y="4407408"/>
+            <a:ext cx="5029200" cy="256032"/>
           </a:xfrm>
           <a:prstGeom prst="rect">
             <a:avLst/>
@@ -6649,8 +6649,8 @@
         </p:nvSpPr>
         <p:spPr>
           <a:xfrm>
-            <a:off x="7680960" y="4709160"/>
-            <a:ext cx="4023360" cy="777240"/>
+            <a:off x="5943600" y="3840480"/>
+            <a:ext cx="5029200" cy="777240"/>
           </a:xfrm>
           <a:prstGeom prst="rect">
             <a:avLst/>
@@ -6673,7 +6673,7 @@
         </p:nvSpPr>
         <p:spPr>
           <a:xfrm>
-            <a:off x="7680960" y="4709160"/>
+            <a:off x="5943600" y="3840480"/>
             <a:ext cx="54864" cy="777240"/>
           </a:xfrm>
           <a:prstGeom prst="rect">
@@ -6697,8 +6697,8 @@
         </p:nvSpPr>
         <p:spPr>
           <a:xfrm>
-            <a:off x="7863840" y="4782312"/>
-            <a:ext cx="3657600" cy="256032"/>
+            <a:off x="6126479" y="3913632"/>
+            <a:ext cx="5029200" cy="256032"/>
           </a:xfrm>
           <a:prstGeom prst="rect">
             <a:avLst/>
@@ -6736,8 +6736,8 @@
         </p:nvSpPr>
         <p:spPr>
           <a:xfrm>
-            <a:off x="7863840" y="5001768"/>
-            <a:ext cx="3657600" cy="329184"/>
+            <a:off x="6126479" y="4133087"/>
+            <a:ext cx="5029200" cy="329184"/>
           </a:xfrm>
           <a:prstGeom prst="rect">
             <a:avLst/>
@@ -6775,8 +6775,8 @@
         </p:nvSpPr>
         <p:spPr>
           <a:xfrm>
-            <a:off x="7863840" y="5276088"/>
-            <a:ext cx="3657600" cy="256032"/>
+            <a:off x="6126479" y="4407407"/>
+            <a:ext cx="5029200" cy="256032"/>
           </a:xfrm>
           <a:prstGeom prst="rect">
             <a:avLst/>

</xml_diff>

<commit_message>
docs: Fix investor pitch — 8.6→8.7億円, 40→33% margin, Edu 100→104W
Slide fixes:
- S11: 累計開発費 8.6億円($5.74M) → 8.7億円($5.78M) — Phase -1 $3.08M反映
- S11: 競合比較 8.6億円 → 8.7億円
- S12: 粗利率 ~40% → ~33% (実効原価$81K基準, bom.md §5.5)
- S12: リターン計算 累計8.6億 → 8.7億
- S6: Edu消費電力 ~100W → ~104W (OPA×2必須, macronode要件)

Co-Authored-By: Claude Opus 4.6 (1M context) <noreply@anthropic.com>
</commit_message>
<xml_diff>
--- a/assets/TAROS_Investor_Pitch_Revised.pptx
+++ b/assets/TAROS_Investor_Pitch_Revised.pptx
@@ -5105,7 +5105,7 @@
                 <a:ea typeface="Arial" pitchFamily="34" charset="-122"/>
                 <a:cs typeface="Arial" pitchFamily="34" charset="-120"/>
               </a:rPr>
-              <a:t>累計開発費 — 量産可能製品まで 約8.6億円 ($5.74M)</a:t>
+              <a:t>累計開発費 — 量産可能製品まで 約8.7億円 ($5.78M)</a:t>
             </a:r>
             <a:endParaRPr lang="en-US" sz="1300" dirty="0"/>
           </a:p>
@@ -5912,7 +5912,7 @@
                 <a:ea typeface="Arial" pitchFamily="34" charset="-122"/>
                 <a:cs typeface="Arial" pitchFamily="34" charset="-120"/>
               </a:rPr>
-              <a:t>約8.6億円</a:t>
+              <a:t>約8.7億円</a:t>
             </a:r>
             <a:endParaRPr lang="en-US" sz="1200" dirty="0"/>
           </a:p>
@@ -6431,7 +6431,7 @@
                 <a:ea typeface="Arial" pitchFamily="34" charset="-122"/>
                 <a:cs typeface="Arial" pitchFamily="34" charset="-120"/>
               </a:rPr>
-              <a:t>~40%</a:t>
+              <a:t>~33%</a:t>
             </a:r>
             <a:endParaRPr lang="en-US" sz="1700" dirty="0"/>
           </a:p>
@@ -6891,7 +6891,7 @@
                 <a:ea typeface="Arial" pitchFamily="34" charset="-122"/>
                 <a:cs typeface="Arial" pitchFamily="34" charset="-120"/>
               </a:rPr>
-              <a:t>(81-90% × 36億 ARR ≈ 30億 / 累計 8.6億)</a:t>
+              <a:t>(81-90% × 36億 ARR ≈ 30億 / 累計 8.7億)</a:t>
             </a:r>
             <a:endParaRPr lang="en-US" sz="1300" dirty="0"/>
           </a:p>
@@ -13633,7 +13633,7 @@
                 <a:ea typeface="Arial" pitchFamily="34" charset="-122"/>
                 <a:cs typeface="Arial" pitchFamily="34" charset="-120"/>
               </a:rPr>
-              <a:t>~100W</a:t>
+              <a:t>~104W</a:t>
             </a:r>
             <a:endParaRPr lang="en-US" sz="1200" dirty="0"/>
           </a:p>

</xml_diff>

<commit_message>
fix: round-3 final verification — 19 issues across 8 files
CRITICAL(1): bom.md B-column SSOT note clarified (09_rack-design.md basis)
HIGH(6): PPTX slide 4 threshold +3.4→+1.8dB, slide 5 p_phys 3→4.9×10⁻³,
  PDF regenerated; fallback/02 SNSPD 500→1000 (manufacturing calc + Go/No-Go
  table 3 rows); 10_portable p_phys 5×10⁻⁴→4.9×10⁻³ (2 spots)
MEDIUM: p_err theoretical limit unified 1.1→1.0×10⁻³ across 13_performance
  and 02_opa-source (calculation chain corrected: UF 7.2→7.0×10⁻⁶);
  bom.md rack power 0.15→0.185kW; 12_mechanical assembly 3h→4.5h (DWG-003)

Co-Authored-By: Claude Opus 4.6 (1M context) <noreply@anthropic.com>
</commit_message>
<xml_diff>
--- a/assets/TAROS_Investor_Pitch_Revised.pptx
+++ b/assets/TAROS_Investor_Pitch_Revised.pptx
@@ -11157,7 +11157,7 @@
                 <a:ea typeface="Arial" pitchFamily="34" charset="-122"/>
                 <a:cs typeface="Arial" pitchFamily="34" charset="-120"/>
               </a:rPr>
-              <a:t>Phase 2+ PIC 統合で +3.4dB マージンを確保</a:t>
+              <a:t>Phase 2+ PIC 統合で +1.8dB マージンを確保</a:t>
             </a:r>
             <a:endParaRPr lang="en-US" sz="1100" dirty="0"/>
           </a:p>
@@ -12317,7 +12317,7 @@
                 <a:ea typeface="Arial" pitchFamily="34" charset="-122"/>
                 <a:cs typeface="Arial" pitchFamily="34" charset="-120"/>
               </a:rPr>
-              <a:t>~3×10⁻³</a:t>
+              <a:t>~4.9×10⁻³</a:t>
             </a:r>
             <a:endParaRPr lang="en-US" sz="2400" dirty="0"/>
           </a:p>

</xml_diff>

<commit_message>
fix: Moonshot slide — 4 future industries redesigned
- 量子脳 NeuroQ: FitzHugh-Nagumo→Schrodinger, C.elegans 302→Drosophila 127K neurons
- 量子シミュレーション 万物の設計者: 創薬P450/PETase, 不老長寿, マテリアル, 重力免疫
- 量子ホログラム QGH: 10^6x QFT, 医療3D可視化, 空間没入フェス
- ヒューマノイドロボット: CIM 50ms制御, SQL超え力覚, NeuroQ統合, $130B市場

Co-Authored-By: Claude Opus 4.6 (1M context) <noreply@anthropic.com>
</commit_message>
<xml_diff>
--- a/assets/TAROS_Investor_Pitch_Revised.pptx
+++ b/assets/TAROS_Investor_Pitch_Revised.pptx
@@ -10670,7 +10670,7 @@
         <p:spPr>
           <a:xfrm>
             <a:off x="548640" y="1645920"/>
-            <a:ext cx="4114800" cy="1463040"/>
+            <a:ext cx="4114800" cy="1554480"/>
           </a:xfrm>
           <a:prstGeom prst="rect">
             <a:avLst/>
@@ -10778,7 +10778,7 @@
               </a:defRPr>
             </a:pPr>
             <a:r>
-              <a:t>量子脳 (NeuroQ)</a:t>
+              <a:t>量子脳 — NeuroQ</a:t>
             </a:r>
           </a:p>
         </p:txBody>
@@ -10791,22 +10791,22 @@
         </p:nvSpPr>
         <p:spPr>
           <a:xfrm>
-            <a:off x="685800" y="2103120"/>
-            <a:ext cx="3840480" cy="914400"/>
-          </a:xfrm>
-          <a:prstGeom prst="rect">
-            <a:avLst/>
-          </a:prstGeom>
-          <a:noFill/>
-        </p:spPr>
-        <p:txBody>
-          <a:bodyPr wrap="square">
-            <a:spAutoFit/>
-          </a:bodyPr>
-          <a:lstStyle/>
-          <a:p>
-            <a:pPr algn="l">
-              <a:defRPr sz="1000" b="0">
+            <a:off x="685800" y="2148840"/>
+            <a:ext cx="3840480" cy="1005840"/>
+          </a:xfrm>
+          <a:prstGeom prst="rect">
+            <a:avLst/>
+          </a:prstGeom>
+          <a:noFill/>
+        </p:spPr>
+        <p:txBody>
+          <a:bodyPr wrap="square">
+            <a:spAutoFit/>
+          </a:bodyPr>
+          <a:lstStyle/>
+          <a:p>
+            <a:pPr algn="l">
+              <a:defRPr sz="900" b="0">
                 <a:solidFill>
                   <a:srgbClr val="B0BEC5"/>
                 </a:solidFill>
@@ -10814,15 +10814,19 @@
               </a:defRPr>
             </a:pPr>
             <a:r>
-              <a:t>CV量子直接互換フレームワーク</a:t>
+              <a:t>FitzHugh-Nagumo神経モデル→Schrödinger変換</a:t>
             </a:r>
             <a:br/>
             <a:r>
-              <a:t>C.elegans 302ニューロン→ロボット知能</a:t>
+              <a:t>→ CV量子で神経回路を直接シミュレーション</a:t>
             </a:r>
             <a:br/>
             <a:r>
-              <a:t>市場: $20B→$130B (2029)</a:t>
+              <a:t>Phase 1: C.elegans 302ニューロン (600 qumode)</a:t>
+            </a:r>
+            <a:br/>
+            <a:r>
+              <a:t>Phase 2+: ショウジョウバエ 127,400ニューロン</a:t>
             </a:r>
           </a:p>
         </p:txBody>
@@ -10836,7 +10840,7 @@
         <p:spPr>
           <a:xfrm>
             <a:off x="7132320" y="1645920"/>
-            <a:ext cx="4480560" cy="1463040"/>
+            <a:ext cx="4480560" cy="1554480"/>
           </a:xfrm>
           <a:prstGeom prst="rect">
             <a:avLst/>
@@ -10944,7 +10948,7 @@
               </a:defRPr>
             </a:pPr>
             <a:r>
-              <a:t>量子ホログラム (QGH)</a:t>
+              <a:t>量子シミュレーション — 万物の設計者</a:t>
             </a:r>
           </a:p>
         </p:txBody>
@@ -10957,22 +10961,22 @@
         </p:nvSpPr>
         <p:spPr>
           <a:xfrm>
-            <a:off x="7269480" y="2103120"/>
-            <a:ext cx="4206240" cy="914400"/>
-          </a:xfrm>
-          <a:prstGeom prst="rect">
-            <a:avLst/>
-          </a:prstGeom>
-          <a:noFill/>
-        </p:spPr>
-        <p:txBody>
-          <a:bodyPr wrap="square">
-            <a:spAutoFit/>
-          </a:bodyPr>
-          <a:lstStyle/>
-          <a:p>
-            <a:pPr algn="l">
-              <a:defRPr sz="1000" b="0">
+            <a:off x="7269480" y="2148840"/>
+            <a:ext cx="4206240" cy="1005840"/>
+          </a:xfrm>
+          <a:prstGeom prst="rect">
+            <a:avLst/>
+          </a:prstGeom>
+          <a:noFill/>
+        </p:spPr>
+        <p:txBody>
+          <a:bodyPr wrap="square">
+            <a:spAutoFit/>
+          </a:bodyPr>
+          <a:lstStyle/>
+          <a:p>
+            <a:pPr algn="l">
+              <a:defRPr sz="900" b="0">
                 <a:solidFill>
                   <a:srgbClr val="B0BEC5"/>
                 </a:solidFill>
@@ -10980,15 +10984,19 @@
               </a:defRPr>
             </a:pPr>
             <a:r>
-              <a:t>QFTで干渉パターンN≈10⁶倍高速計算</a:t>
+              <a:t>創薬: P450精度 71%→94% / PETase 87×活性</a:t>
             </a:r>
             <a:br/>
             <a:r>
-              <a:t>GKPフーリエ構造=ホログラム構造</a:t>
+              <a:t>不老長寿: プロトントンネリング(DNA変異4×)</a:t>
             </a:r>
             <a:br/>
             <a:r>
-              <a:t>6G要件: 4.32Tbps</a:t>
+              <a:t>マテリアル / 仮想生物 / Bose-Hubbard</a:t>
+            </a:r>
+            <a:br/>
+            <a:r>
+              <a:t>宇宙: 光子m=0 → 量子重力デコヒーレンス免疫</a:t>
             </a:r>
           </a:p>
         </p:txBody>
@@ -11002,7 +11010,7 @@
         <p:spPr>
           <a:xfrm>
             <a:off x="548640" y="4572000"/>
-            <a:ext cx="4114800" cy="1463040"/>
+            <a:ext cx="4114800" cy="1554480"/>
           </a:xfrm>
           <a:prstGeom prst="rect">
             <a:avLst/>
@@ -11110,7 +11118,7 @@
               </a:defRPr>
             </a:pPr>
             <a:r>
-              <a:t>量子創薬・不老長寿</a:t>
+              <a:t>量子ホログラム — QGH</a:t>
             </a:r>
           </a:p>
         </p:txBody>
@@ -11123,22 +11131,22 @@
         </p:nvSpPr>
         <p:spPr>
           <a:xfrm>
-            <a:off x="685800" y="5029200"/>
-            <a:ext cx="3840480" cy="914400"/>
-          </a:xfrm>
-          <a:prstGeom prst="rect">
-            <a:avLst/>
-          </a:prstGeom>
-          <a:noFill/>
-        </p:spPr>
-        <p:txBody>
-          <a:bodyPr wrap="square">
-            <a:spAutoFit/>
-          </a:bodyPr>
-          <a:lstStyle/>
-          <a:p>
-            <a:pPr algn="l">
-              <a:defRPr sz="1000" b="0">
+            <a:off x="685800" y="5074920"/>
+            <a:ext cx="3840480" cy="1005840"/>
+          </a:xfrm>
+          <a:prstGeom prst="rect">
+            <a:avLst/>
+          </a:prstGeom>
+          <a:noFill/>
+        </p:spPr>
+        <p:txBody>
+          <a:bodyPr wrap="square">
+            <a:spAutoFit/>
+          </a:bodyPr>
+          <a:lstStyle/>
+          <a:p>
+            <a:pPr algn="l">
+              <a:defRPr sz="900" b="0">
                 <a:solidFill>
                   <a:srgbClr val="B0BEC5"/>
                 </a:solidFill>
@@ -11146,15 +11154,19 @@
               </a:defRPr>
             </a:pPr>
             <a:r>
-              <a:t>プロトントンネリング(DNA変異の量子起源)</a:t>
+              <a:t>QFT: O(N×d³)→O(d³) 10⁶×高速化</a:t>
             </a:r>
             <a:br/>
             <a:r>
-              <a:t>セノリティクス分子の量子設計</a:t>
+              <a:t>GKPフーリエ構造 = ホログラム構造</a:t>
             </a:r>
             <a:br/>
             <a:r>
-              <a:t>P450精度 71%→94%</a:t>
+              <a:t>医療: 分子→細胞→臓器の量子3D可視化</a:t>
+            </a:r>
+            <a:br/>
+            <a:r>
+              <a:t>エンタメ: 空間没入ホログラムフェス / 6G対応</a:t>
             </a:r>
           </a:p>
         </p:txBody>
@@ -11168,7 +11180,7 @@
         <p:spPr>
           <a:xfrm>
             <a:off x="7132320" y="4572000"/>
-            <a:ext cx="4480560" cy="1463040"/>
+            <a:ext cx="4480560" cy="1554480"/>
           </a:xfrm>
           <a:prstGeom prst="rect">
             <a:avLst/>
@@ -11276,7 +11288,7 @@
               </a:defRPr>
             </a:pPr>
             <a:r>
-              <a:t>ロボット知能</a:t>
+              <a:t>ヒューマノイドロボット</a:t>
             </a:r>
           </a:p>
         </p:txBody>
@@ -11289,22 +11301,22 @@
         </p:nvSpPr>
         <p:spPr>
           <a:xfrm>
-            <a:off x="7269480" y="5029200"/>
-            <a:ext cx="4206240" cy="914400"/>
-          </a:xfrm>
-          <a:prstGeom prst="rect">
-            <a:avLst/>
-          </a:prstGeom>
-          <a:noFill/>
-        </p:spPr>
-        <p:txBody>
-          <a:bodyPr wrap="square">
-            <a:spAutoFit/>
-          </a:bodyPr>
-          <a:lstStyle/>
-          <a:p>
-            <a:pPr algn="l">
-              <a:defRPr sz="1000" b="0">
+            <a:off x="7269480" y="5074920"/>
+            <a:ext cx="4206240" cy="1005840"/>
+          </a:xfrm>
+          <a:prstGeom prst="rect">
+            <a:avLst/>
+          </a:prstGeom>
+          <a:noFill/>
+        </p:spPr>
+        <p:txBody>
+          <a:bodyPr wrap="square">
+            <a:spAutoFit/>
+          </a:bodyPr>
+          <a:lstStyle/>
+          <a:p>
+            <a:pPr algn="l">
+              <a:defRPr sz="900" b="0">
                 <a:solidFill>
                   <a:srgbClr val="B0BEC5"/>
                 </a:solidFill>
@@ -11312,15 +11324,19 @@
               </a:defRPr>
             </a:pPr>
             <a:r>
-              <a:t>CIMで50ms制御壁突破</a:t>
+              <a:t>CIM経路最適化で50ms制御壁を突破</a:t>
             </a:r>
             <a:br/>
             <a:r>
-              <a:t>スクイーズド光でSQL超え力覚</a:t>
+              <a:t>スクイーズド光でSQL超え力覚フィードバック</a:t>
             </a:r>
             <a:br/>
             <a:r>
-              <a:t>量子モジュール供給TAM ~$500M</a:t>
+              <a:t>NeuroQ量子脳→ロボット運動制御を直接駆動</a:t>
+            </a:r>
+            <a:br/>
+            <a:r>
+              <a:t>ロボット市場 $20B→$130B / モジュールTAM $500M</a:t>
             </a:r>
           </a:p>
         </p:txBody>

</xml_diff>

<commit_message>
fix: SSOT verification — competitor funding aligned, Slide 9 layout fixed
- Slide 13: Competitor fundraising aligned with SSOT
  PsiQuantum 1,500→1,050億円, IonQ 1,350→900億円, Xanadu 560→375億円
- Slide 9: Table and concentric circles no longer overlap
  Restructured to top-bottom layout (full-width table + centered circles)
- SOM circle enlarged to prevent text wrapping

Verified all 17 slides against design SSOT (2-team review):
- 50+ claims checked, 1 critical fix applied (competitor funding)
- All technical specs (σ_eff, p_L, power, weight, price) confirmed

Co-Authored-By: Claude Opus 4.6 (1M context) <noreply@anthropic.com>
</commit_message>
<xml_diff>
--- a/assets/TAROS_Investor_Pitch_Revised.pptx
+++ b/assets/TAROS_Investor_Pitch_Revised.pptx
@@ -8591,7 +8591,7 @@
               </a:defRPr>
             </a:pPr>
             <a:r>
-              <a:t>約1,500億円超</a:t>
+              <a:t>約1,050億円超</a:t>
             </a:r>
           </a:p>
         </p:txBody>
@@ -8605,7 +8605,7 @@
         <p:spPr>
           <a:xfrm>
             <a:off x="2286000" y="4892040"/>
-            <a:ext cx="7406640" cy="365760"/>
+            <a:ext cx="7040880" cy="365760"/>
           </a:xfrm>
           <a:prstGeom prst="rect">
             <a:avLst/>
@@ -8683,7 +8683,7 @@
         </p:nvSpPr>
         <p:spPr>
           <a:xfrm>
-            <a:off x="9829800" y="4910327"/>
+            <a:off x="9464040" y="4910327"/>
             <a:ext cx="2286000" cy="320040"/>
           </a:xfrm>
           <a:prstGeom prst="rect">
@@ -8706,7 +8706,7 @@
               </a:defRPr>
             </a:pPr>
             <a:r>
-              <a:t>約1,350億円</a:t>
+              <a:t>約900億円超</a:t>
             </a:r>
           </a:p>
         </p:txBody>
@@ -8720,7 +8720,7 @@
         <p:spPr>
           <a:xfrm>
             <a:off x="2286000" y="5394960"/>
-            <a:ext cx="3108960" cy="365760"/>
+            <a:ext cx="2926080" cy="365760"/>
           </a:xfrm>
           <a:prstGeom prst="rect">
             <a:avLst/>
@@ -8798,7 +8798,7 @@
         </p:nvSpPr>
         <p:spPr>
           <a:xfrm>
-            <a:off x="5532120" y="5413248"/>
+            <a:off x="5349240" y="5413248"/>
             <a:ext cx="2286000" cy="320040"/>
           </a:xfrm>
           <a:prstGeom prst="rect">
@@ -8821,7 +8821,7 @@
               </a:defRPr>
             </a:pPr>
             <a:r>
-              <a:t>約560億円</a:t>
+              <a:t>約375億円超</a:t>
             </a:r>
           </a:p>
         </p:txBody>
@@ -24236,7 +24236,7 @@
         <p:spPr>
           <a:xfrm>
             <a:off x="548640" y="1691640"/>
-            <a:ext cx="1188720" cy="320040"/>
+            <a:ext cx="1783080" cy="320040"/>
           </a:xfrm>
           <a:prstGeom prst="rect">
             <a:avLst/>
@@ -24278,22 +24278,22 @@
         </p:nvSpPr>
         <p:spPr>
           <a:xfrm>
-            <a:off x="594360" y="1709928"/>
-            <a:ext cx="1097280" cy="274320"/>
-          </a:xfrm>
-          <a:prstGeom prst="rect">
-            <a:avLst/>
-          </a:prstGeom>
-          <a:noFill/>
-        </p:spPr>
-        <p:txBody>
-          <a:bodyPr wrap="square">
-            <a:spAutoFit/>
-          </a:bodyPr>
-          <a:lstStyle/>
-          <a:p>
-            <a:pPr algn="l">
-              <a:defRPr sz="800" b="1">
+            <a:off x="621792" y="1709928"/>
+            <a:ext cx="1645920" cy="274320"/>
+          </a:xfrm>
+          <a:prstGeom prst="rect">
+            <a:avLst/>
+          </a:prstGeom>
+          <a:noFill/>
+        </p:spPr>
+        <p:txBody>
+          <a:bodyPr wrap="square">
+            <a:spAutoFit/>
+          </a:bodyPr>
+          <a:lstStyle/>
+          <a:p>
+            <a:pPr algn="l">
+              <a:defRPr sz="900" b="1">
                 <a:solidFill>
                   <a:srgbClr val="FFFFFF"/>
                 </a:solidFill>
@@ -24314,8 +24314,8 @@
         </p:nvSpPr>
         <p:spPr>
           <a:xfrm>
-            <a:off x="1783080" y="1691640"/>
-            <a:ext cx="1188720" cy="320040"/>
+            <a:off x="2377440" y="1691640"/>
+            <a:ext cx="1783080" cy="320040"/>
           </a:xfrm>
           <a:prstGeom prst="rect">
             <a:avLst/>
@@ -24357,22 +24357,22 @@
         </p:nvSpPr>
         <p:spPr>
           <a:xfrm>
-            <a:off x="1828800" y="1709928"/>
-            <a:ext cx="1097280" cy="274320"/>
-          </a:xfrm>
-          <a:prstGeom prst="rect">
-            <a:avLst/>
-          </a:prstGeom>
-          <a:noFill/>
-        </p:spPr>
-        <p:txBody>
-          <a:bodyPr wrap="square">
-            <a:spAutoFit/>
-          </a:bodyPr>
-          <a:lstStyle/>
-          <a:p>
-            <a:pPr algn="l">
-              <a:defRPr sz="800" b="1">
+            <a:off x="2450592" y="1709928"/>
+            <a:ext cx="1645920" cy="274320"/>
+          </a:xfrm>
+          <a:prstGeom prst="rect">
+            <a:avLst/>
+          </a:prstGeom>
+          <a:noFill/>
+        </p:spPr>
+        <p:txBody>
+          <a:bodyPr wrap="square">
+            <a:spAutoFit/>
+          </a:bodyPr>
+          <a:lstStyle/>
+          <a:p>
+            <a:pPr algn="l">
+              <a:defRPr sz="900" b="1">
                 <a:solidFill>
                   <a:srgbClr val="FFFFFF"/>
                 </a:solidFill>
@@ -24393,8 +24393,8 @@
         </p:nvSpPr>
         <p:spPr>
           <a:xfrm>
-            <a:off x="3017520" y="1691640"/>
-            <a:ext cx="1188720" cy="320040"/>
+            <a:off x="4206240" y="1691640"/>
+            <a:ext cx="1783080" cy="320040"/>
           </a:xfrm>
           <a:prstGeom prst="rect">
             <a:avLst/>
@@ -24436,22 +24436,22 @@
         </p:nvSpPr>
         <p:spPr>
           <a:xfrm>
-            <a:off x="3063240" y="1709928"/>
-            <a:ext cx="1097280" cy="274320"/>
-          </a:xfrm>
-          <a:prstGeom prst="rect">
-            <a:avLst/>
-          </a:prstGeom>
-          <a:noFill/>
-        </p:spPr>
-        <p:txBody>
-          <a:bodyPr wrap="square">
-            <a:spAutoFit/>
-          </a:bodyPr>
-          <a:lstStyle/>
-          <a:p>
-            <a:pPr algn="l">
-              <a:defRPr sz="800" b="1">
+            <a:off x="4279392" y="1709928"/>
+            <a:ext cx="1645920" cy="274320"/>
+          </a:xfrm>
+          <a:prstGeom prst="rect">
+            <a:avLst/>
+          </a:prstGeom>
+          <a:noFill/>
+        </p:spPr>
+        <p:txBody>
+          <a:bodyPr wrap="square">
+            <a:spAutoFit/>
+          </a:bodyPr>
+          <a:lstStyle/>
+          <a:p>
+            <a:pPr algn="l">
+              <a:defRPr sz="900" b="1">
                 <a:solidFill>
                   <a:srgbClr val="FFFFFF"/>
                 </a:solidFill>
@@ -24472,8 +24472,8 @@
         </p:nvSpPr>
         <p:spPr>
           <a:xfrm>
-            <a:off x="4251960" y="1691640"/>
-            <a:ext cx="1188720" cy="320040"/>
+            <a:off x="6035040" y="1691640"/>
+            <a:ext cx="1783080" cy="320040"/>
           </a:xfrm>
           <a:prstGeom prst="rect">
             <a:avLst/>
@@ -24515,22 +24515,22 @@
         </p:nvSpPr>
         <p:spPr>
           <a:xfrm>
-            <a:off x="4297680" y="1709928"/>
-            <a:ext cx="1097280" cy="274320"/>
-          </a:xfrm>
-          <a:prstGeom prst="rect">
-            <a:avLst/>
-          </a:prstGeom>
-          <a:noFill/>
-        </p:spPr>
-        <p:txBody>
-          <a:bodyPr wrap="square">
-            <a:spAutoFit/>
-          </a:bodyPr>
-          <a:lstStyle/>
-          <a:p>
-            <a:pPr algn="l">
-              <a:defRPr sz="800" b="1">
+            <a:off x="6108192" y="1709928"/>
+            <a:ext cx="1645920" cy="274320"/>
+          </a:xfrm>
+          <a:prstGeom prst="rect">
+            <a:avLst/>
+          </a:prstGeom>
+          <a:noFill/>
+        </p:spPr>
+        <p:txBody>
+          <a:bodyPr wrap="square">
+            <a:spAutoFit/>
+          </a:bodyPr>
+          <a:lstStyle/>
+          <a:p>
+            <a:pPr algn="l">
+              <a:defRPr sz="900" b="1">
                 <a:solidFill>
                   <a:srgbClr val="FFFFFF"/>
                 </a:solidFill>
@@ -24551,8 +24551,8 @@
         </p:nvSpPr>
         <p:spPr>
           <a:xfrm>
-            <a:off x="5486400" y="1691640"/>
-            <a:ext cx="1188720" cy="320040"/>
+            <a:off x="7863840" y="1691640"/>
+            <a:ext cx="1783080" cy="320040"/>
           </a:xfrm>
           <a:prstGeom prst="rect">
             <a:avLst/>
@@ -24594,22 +24594,22 @@
         </p:nvSpPr>
         <p:spPr>
           <a:xfrm>
-            <a:off x="5532120" y="1709928"/>
-            <a:ext cx="1097280" cy="274320"/>
-          </a:xfrm>
-          <a:prstGeom prst="rect">
-            <a:avLst/>
-          </a:prstGeom>
-          <a:noFill/>
-        </p:spPr>
-        <p:txBody>
-          <a:bodyPr wrap="square">
-            <a:spAutoFit/>
-          </a:bodyPr>
-          <a:lstStyle/>
-          <a:p>
-            <a:pPr algn="l">
-              <a:defRPr sz="800" b="1">
+            <a:off x="7936992" y="1709928"/>
+            <a:ext cx="1645920" cy="274320"/>
+          </a:xfrm>
+          <a:prstGeom prst="rect">
+            <a:avLst/>
+          </a:prstGeom>
+          <a:noFill/>
+        </p:spPr>
+        <p:txBody>
+          <a:bodyPr wrap="square">
+            <a:spAutoFit/>
+          </a:bodyPr>
+          <a:lstStyle/>
+          <a:p>
+            <a:pPr algn="l">
+              <a:defRPr sz="900" b="1">
                 <a:solidFill>
                   <a:srgbClr val="FFFFFF"/>
                 </a:solidFill>
@@ -24630,8 +24630,8 @@
         </p:nvSpPr>
         <p:spPr>
           <a:xfrm>
-            <a:off x="6720840" y="1691640"/>
-            <a:ext cx="1188720" cy="320040"/>
+            <a:off x="9692640" y="1691640"/>
+            <a:ext cx="1783080" cy="320040"/>
           </a:xfrm>
           <a:prstGeom prst="rect">
             <a:avLst/>
@@ -24673,22 +24673,22 @@
         </p:nvSpPr>
         <p:spPr>
           <a:xfrm>
-            <a:off x="6766559" y="1709928"/>
-            <a:ext cx="1097280" cy="274320"/>
-          </a:xfrm>
-          <a:prstGeom prst="rect">
-            <a:avLst/>
-          </a:prstGeom>
-          <a:noFill/>
-        </p:spPr>
-        <p:txBody>
-          <a:bodyPr wrap="square">
-            <a:spAutoFit/>
-          </a:bodyPr>
-          <a:lstStyle/>
-          <a:p>
-            <a:pPr algn="l">
-              <a:defRPr sz="800" b="1">
+            <a:off x="9765792" y="1709928"/>
+            <a:ext cx="1645920" cy="274320"/>
+          </a:xfrm>
+          <a:prstGeom prst="rect">
+            <a:avLst/>
+          </a:prstGeom>
+          <a:noFill/>
+        </p:spPr>
+        <p:txBody>
+          <a:bodyPr wrap="square">
+            <a:spAutoFit/>
+          </a:bodyPr>
+          <a:lstStyle/>
+          <a:p>
+            <a:pPr algn="l">
+              <a:defRPr sz="900" b="1">
                 <a:solidFill>
                   <a:srgbClr val="FFFFFF"/>
                 </a:solidFill>
@@ -24710,7 +24710,7 @@
         <p:spPr>
           <a:xfrm>
             <a:off x="548640" y="2057400"/>
-            <a:ext cx="1188720" cy="329184"/>
+            <a:ext cx="1783080" cy="329184"/>
           </a:xfrm>
           <a:prstGeom prst="rect">
             <a:avLst/>
@@ -24752,22 +24752,22 @@
         </p:nvSpPr>
         <p:spPr>
           <a:xfrm>
-            <a:off x="594360" y="2075688"/>
-            <a:ext cx="1097280" cy="274320"/>
-          </a:xfrm>
-          <a:prstGeom prst="rect">
-            <a:avLst/>
-          </a:prstGeom>
-          <a:noFill/>
-        </p:spPr>
-        <p:txBody>
-          <a:bodyPr wrap="square">
-            <a:spAutoFit/>
-          </a:bodyPr>
-          <a:lstStyle/>
-          <a:p>
-            <a:pPr algn="l">
-              <a:defRPr sz="800" b="0">
+            <a:off x="621792" y="2075688"/>
+            <a:ext cx="1645920" cy="274320"/>
+          </a:xfrm>
+          <a:prstGeom prst="rect">
+            <a:avLst/>
+          </a:prstGeom>
+          <a:noFill/>
+        </p:spPr>
+        <p:txBody>
+          <a:bodyPr wrap="square">
+            <a:spAutoFit/>
+          </a:bodyPr>
+          <a:lstStyle/>
+          <a:p>
+            <a:pPr algn="l">
+              <a:defRPr sz="900" b="0">
                 <a:solidFill>
                   <a:srgbClr val="212121"/>
                 </a:solidFill>
@@ -24788,8 +24788,8 @@
         </p:nvSpPr>
         <p:spPr>
           <a:xfrm>
-            <a:off x="1783080" y="2057400"/>
-            <a:ext cx="1188720" cy="329184"/>
+            <a:off x="2377440" y="2057400"/>
+            <a:ext cx="1783080" cy="329184"/>
           </a:xfrm>
           <a:prstGeom prst="rect">
             <a:avLst/>
@@ -24831,22 +24831,22 @@
         </p:nvSpPr>
         <p:spPr>
           <a:xfrm>
-            <a:off x="1828800" y="2075688"/>
-            <a:ext cx="1097280" cy="274320"/>
-          </a:xfrm>
-          <a:prstGeom prst="rect">
-            <a:avLst/>
-          </a:prstGeom>
-          <a:noFill/>
-        </p:spPr>
-        <p:txBody>
-          <a:bodyPr wrap="square">
-            <a:spAutoFit/>
-          </a:bodyPr>
-          <a:lstStyle/>
-          <a:p>
-            <a:pPr algn="l">
-              <a:defRPr sz="800" b="0">
+            <a:off x="2450592" y="2075688"/>
+            <a:ext cx="1645920" cy="274320"/>
+          </a:xfrm>
+          <a:prstGeom prst="rect">
+            <a:avLst/>
+          </a:prstGeom>
+          <a:noFill/>
+        </p:spPr>
+        <p:txBody>
+          <a:bodyPr wrap="square">
+            <a:spAutoFit/>
+          </a:bodyPr>
+          <a:lstStyle/>
+          <a:p>
+            <a:pPr algn="l">
+              <a:defRPr sz="900" b="0">
                 <a:solidFill>
                   <a:srgbClr val="212121"/>
                 </a:solidFill>
@@ -24867,8 +24867,8 @@
         </p:nvSpPr>
         <p:spPr>
           <a:xfrm>
-            <a:off x="3017520" y="2057400"/>
-            <a:ext cx="1188720" cy="329184"/>
+            <a:off x="4206240" y="2057400"/>
+            <a:ext cx="1783080" cy="329184"/>
           </a:xfrm>
           <a:prstGeom prst="rect">
             <a:avLst/>
@@ -24910,22 +24910,22 @@
         </p:nvSpPr>
         <p:spPr>
           <a:xfrm>
-            <a:off x="3063240" y="2075688"/>
-            <a:ext cx="1097280" cy="274320"/>
-          </a:xfrm>
-          <a:prstGeom prst="rect">
-            <a:avLst/>
-          </a:prstGeom>
-          <a:noFill/>
-        </p:spPr>
-        <p:txBody>
-          <a:bodyPr wrap="square">
-            <a:spAutoFit/>
-          </a:bodyPr>
-          <a:lstStyle/>
-          <a:p>
-            <a:pPr algn="l">
-              <a:defRPr sz="800" b="0">
+            <a:off x="4279392" y="2075688"/>
+            <a:ext cx="1645920" cy="274320"/>
+          </a:xfrm>
+          <a:prstGeom prst="rect">
+            <a:avLst/>
+          </a:prstGeom>
+          <a:noFill/>
+        </p:spPr>
+        <p:txBody>
+          <a:bodyPr wrap="square">
+            <a:spAutoFit/>
+          </a:bodyPr>
+          <a:lstStyle/>
+          <a:p>
+            <a:pPr algn="l">
+              <a:defRPr sz="900" b="0">
                 <a:solidFill>
                   <a:srgbClr val="212121"/>
                 </a:solidFill>
@@ -24946,8 +24946,8 @@
         </p:nvSpPr>
         <p:spPr>
           <a:xfrm>
-            <a:off x="4251960" y="2057400"/>
-            <a:ext cx="1188720" cy="329184"/>
+            <a:off x="6035040" y="2057400"/>
+            <a:ext cx="1783080" cy="329184"/>
           </a:xfrm>
           <a:prstGeom prst="rect">
             <a:avLst/>
@@ -24989,22 +24989,22 @@
         </p:nvSpPr>
         <p:spPr>
           <a:xfrm>
-            <a:off x="4297680" y="2075688"/>
-            <a:ext cx="1097280" cy="274320"/>
-          </a:xfrm>
-          <a:prstGeom prst="rect">
-            <a:avLst/>
-          </a:prstGeom>
-          <a:noFill/>
-        </p:spPr>
-        <p:txBody>
-          <a:bodyPr wrap="square">
-            <a:spAutoFit/>
-          </a:bodyPr>
-          <a:lstStyle/>
-          <a:p>
-            <a:pPr algn="l">
-              <a:defRPr sz="800" b="0">
+            <a:off x="6108192" y="2075688"/>
+            <a:ext cx="1645920" cy="274320"/>
+          </a:xfrm>
+          <a:prstGeom prst="rect">
+            <a:avLst/>
+          </a:prstGeom>
+          <a:noFill/>
+        </p:spPr>
+        <p:txBody>
+          <a:bodyPr wrap="square">
+            <a:spAutoFit/>
+          </a:bodyPr>
+          <a:lstStyle/>
+          <a:p>
+            <a:pPr algn="l">
+              <a:defRPr sz="900" b="0">
                 <a:solidFill>
                   <a:srgbClr val="212121"/>
                 </a:solidFill>
@@ -25025,8 +25025,8 @@
         </p:nvSpPr>
         <p:spPr>
           <a:xfrm>
-            <a:off x="5486400" y="2057400"/>
-            <a:ext cx="1188720" cy="329184"/>
+            <a:off x="7863840" y="2057400"/>
+            <a:ext cx="1783080" cy="329184"/>
           </a:xfrm>
           <a:prstGeom prst="rect">
             <a:avLst/>
@@ -25068,22 +25068,22 @@
         </p:nvSpPr>
         <p:spPr>
           <a:xfrm>
-            <a:off x="5532120" y="2075688"/>
-            <a:ext cx="1097280" cy="274320"/>
-          </a:xfrm>
-          <a:prstGeom prst="rect">
-            <a:avLst/>
-          </a:prstGeom>
-          <a:noFill/>
-        </p:spPr>
-        <p:txBody>
-          <a:bodyPr wrap="square">
-            <a:spAutoFit/>
-          </a:bodyPr>
-          <a:lstStyle/>
-          <a:p>
-            <a:pPr algn="l">
-              <a:defRPr sz="800" b="0">
+            <a:off x="7936992" y="2075688"/>
+            <a:ext cx="1645920" cy="274320"/>
+          </a:xfrm>
+          <a:prstGeom prst="rect">
+            <a:avLst/>
+          </a:prstGeom>
+          <a:noFill/>
+        </p:spPr>
+        <p:txBody>
+          <a:bodyPr wrap="square">
+            <a:spAutoFit/>
+          </a:bodyPr>
+          <a:lstStyle/>
+          <a:p>
+            <a:pPr algn="l">
+              <a:defRPr sz="900" b="0">
                 <a:solidFill>
                   <a:srgbClr val="212121"/>
                 </a:solidFill>
@@ -25104,8 +25104,8 @@
         </p:nvSpPr>
         <p:spPr>
           <a:xfrm>
-            <a:off x="6720840" y="2057400"/>
-            <a:ext cx="1188720" cy="329184"/>
+            <a:off x="9692640" y="2057400"/>
+            <a:ext cx="1783080" cy="329184"/>
           </a:xfrm>
           <a:prstGeom prst="rect">
             <a:avLst/>
@@ -25147,22 +25147,22 @@
         </p:nvSpPr>
         <p:spPr>
           <a:xfrm>
-            <a:off x="6766559" y="2075688"/>
-            <a:ext cx="1097280" cy="274320"/>
-          </a:xfrm>
-          <a:prstGeom prst="rect">
-            <a:avLst/>
-          </a:prstGeom>
-          <a:noFill/>
-        </p:spPr>
-        <p:txBody>
-          <a:bodyPr wrap="square">
-            <a:spAutoFit/>
-          </a:bodyPr>
-          <a:lstStyle/>
-          <a:p>
-            <a:pPr algn="l">
-              <a:defRPr sz="800" b="0">
+            <a:off x="9765792" y="2075688"/>
+            <a:ext cx="1645920" cy="274320"/>
+          </a:xfrm>
+          <a:prstGeom prst="rect">
+            <a:avLst/>
+          </a:prstGeom>
+          <a:noFill/>
+        </p:spPr>
+        <p:txBody>
+          <a:bodyPr wrap="square">
+            <a:spAutoFit/>
+          </a:bodyPr>
+          <a:lstStyle/>
+          <a:p>
+            <a:pPr algn="l">
+              <a:defRPr sz="900" b="0">
                 <a:solidFill>
                   <a:srgbClr val="212121"/>
                 </a:solidFill>
@@ -25184,7 +25184,7 @@
         <p:spPr>
           <a:xfrm>
             <a:off x="548640" y="2404872"/>
-            <a:ext cx="1188720" cy="329184"/>
+            <a:ext cx="1783080" cy="329184"/>
           </a:xfrm>
           <a:prstGeom prst="rect">
             <a:avLst/>
@@ -25226,22 +25226,22 @@
         </p:nvSpPr>
         <p:spPr>
           <a:xfrm>
-            <a:off x="594360" y="2423160"/>
-            <a:ext cx="1097280" cy="274320"/>
-          </a:xfrm>
-          <a:prstGeom prst="rect">
-            <a:avLst/>
-          </a:prstGeom>
-          <a:noFill/>
-        </p:spPr>
-        <p:txBody>
-          <a:bodyPr wrap="square">
-            <a:spAutoFit/>
-          </a:bodyPr>
-          <a:lstStyle/>
-          <a:p>
-            <a:pPr algn="l">
-              <a:defRPr sz="800" b="0">
+            <a:off x="621792" y="2423160"/>
+            <a:ext cx="1645920" cy="274320"/>
+          </a:xfrm>
+          <a:prstGeom prst="rect">
+            <a:avLst/>
+          </a:prstGeom>
+          <a:noFill/>
+        </p:spPr>
+        <p:txBody>
+          <a:bodyPr wrap="square">
+            <a:spAutoFit/>
+          </a:bodyPr>
+          <a:lstStyle/>
+          <a:p>
+            <a:pPr algn="l">
+              <a:defRPr sz="900" b="0">
                 <a:solidFill>
                   <a:srgbClr val="212121"/>
                 </a:solidFill>
@@ -25262,8 +25262,8 @@
         </p:nvSpPr>
         <p:spPr>
           <a:xfrm>
-            <a:off x="1783080" y="2404872"/>
-            <a:ext cx="1188720" cy="329184"/>
+            <a:off x="2377440" y="2404872"/>
+            <a:ext cx="1783080" cy="329184"/>
           </a:xfrm>
           <a:prstGeom prst="rect">
             <a:avLst/>
@@ -25305,22 +25305,22 @@
         </p:nvSpPr>
         <p:spPr>
           <a:xfrm>
-            <a:off x="1828800" y="2423160"/>
-            <a:ext cx="1097280" cy="274320"/>
-          </a:xfrm>
-          <a:prstGeom prst="rect">
-            <a:avLst/>
-          </a:prstGeom>
-          <a:noFill/>
-        </p:spPr>
-        <p:txBody>
-          <a:bodyPr wrap="square">
-            <a:spAutoFit/>
-          </a:bodyPr>
-          <a:lstStyle/>
-          <a:p>
-            <a:pPr algn="l">
-              <a:defRPr sz="800" b="0">
+            <a:off x="2450592" y="2423160"/>
+            <a:ext cx="1645920" cy="274320"/>
+          </a:xfrm>
+          <a:prstGeom prst="rect">
+            <a:avLst/>
+          </a:prstGeom>
+          <a:noFill/>
+        </p:spPr>
+        <p:txBody>
+          <a:bodyPr wrap="square">
+            <a:spAutoFit/>
+          </a:bodyPr>
+          <a:lstStyle/>
+          <a:p>
+            <a:pPr algn="l">
+              <a:defRPr sz="900" b="0">
                 <a:solidFill>
                   <a:srgbClr val="212121"/>
                 </a:solidFill>
@@ -25341,8 +25341,8 @@
         </p:nvSpPr>
         <p:spPr>
           <a:xfrm>
-            <a:off x="3017520" y="2404872"/>
-            <a:ext cx="1188720" cy="329184"/>
+            <a:off x="4206240" y="2404872"/>
+            <a:ext cx="1783080" cy="329184"/>
           </a:xfrm>
           <a:prstGeom prst="rect">
             <a:avLst/>
@@ -25384,22 +25384,22 @@
         </p:nvSpPr>
         <p:spPr>
           <a:xfrm>
-            <a:off x="3063240" y="2423160"/>
-            <a:ext cx="1097280" cy="274320"/>
-          </a:xfrm>
-          <a:prstGeom prst="rect">
-            <a:avLst/>
-          </a:prstGeom>
-          <a:noFill/>
-        </p:spPr>
-        <p:txBody>
-          <a:bodyPr wrap="square">
-            <a:spAutoFit/>
-          </a:bodyPr>
-          <a:lstStyle/>
-          <a:p>
-            <a:pPr algn="l">
-              <a:defRPr sz="800" b="0">
+            <a:off x="4279392" y="2423160"/>
+            <a:ext cx="1645920" cy="274320"/>
+          </a:xfrm>
+          <a:prstGeom prst="rect">
+            <a:avLst/>
+          </a:prstGeom>
+          <a:noFill/>
+        </p:spPr>
+        <p:txBody>
+          <a:bodyPr wrap="square">
+            <a:spAutoFit/>
+          </a:bodyPr>
+          <a:lstStyle/>
+          <a:p>
+            <a:pPr algn="l">
+              <a:defRPr sz="900" b="0">
                 <a:solidFill>
                   <a:srgbClr val="212121"/>
                 </a:solidFill>
@@ -25420,8 +25420,8 @@
         </p:nvSpPr>
         <p:spPr>
           <a:xfrm>
-            <a:off x="4251960" y="2404872"/>
-            <a:ext cx="1188720" cy="329184"/>
+            <a:off x="6035040" y="2404872"/>
+            <a:ext cx="1783080" cy="329184"/>
           </a:xfrm>
           <a:prstGeom prst="rect">
             <a:avLst/>
@@ -25463,22 +25463,22 @@
         </p:nvSpPr>
         <p:spPr>
           <a:xfrm>
-            <a:off x="4297680" y="2423160"/>
-            <a:ext cx="1097280" cy="274320"/>
-          </a:xfrm>
-          <a:prstGeom prst="rect">
-            <a:avLst/>
-          </a:prstGeom>
-          <a:noFill/>
-        </p:spPr>
-        <p:txBody>
-          <a:bodyPr wrap="square">
-            <a:spAutoFit/>
-          </a:bodyPr>
-          <a:lstStyle/>
-          <a:p>
-            <a:pPr algn="l">
-              <a:defRPr sz="800" b="0">
+            <a:off x="6108192" y="2423160"/>
+            <a:ext cx="1645920" cy="274320"/>
+          </a:xfrm>
+          <a:prstGeom prst="rect">
+            <a:avLst/>
+          </a:prstGeom>
+          <a:noFill/>
+        </p:spPr>
+        <p:txBody>
+          <a:bodyPr wrap="square">
+            <a:spAutoFit/>
+          </a:bodyPr>
+          <a:lstStyle/>
+          <a:p>
+            <a:pPr algn="l">
+              <a:defRPr sz="900" b="0">
                 <a:solidFill>
                   <a:srgbClr val="212121"/>
                 </a:solidFill>
@@ -25499,8 +25499,8 @@
         </p:nvSpPr>
         <p:spPr>
           <a:xfrm>
-            <a:off x="5486400" y="2404872"/>
-            <a:ext cx="1188720" cy="329184"/>
+            <a:off x="7863840" y="2404872"/>
+            <a:ext cx="1783080" cy="329184"/>
           </a:xfrm>
           <a:prstGeom prst="rect">
             <a:avLst/>
@@ -25542,22 +25542,22 @@
         </p:nvSpPr>
         <p:spPr>
           <a:xfrm>
-            <a:off x="5532120" y="2423160"/>
-            <a:ext cx="1097280" cy="274320"/>
-          </a:xfrm>
-          <a:prstGeom prst="rect">
-            <a:avLst/>
-          </a:prstGeom>
-          <a:noFill/>
-        </p:spPr>
-        <p:txBody>
-          <a:bodyPr wrap="square">
-            <a:spAutoFit/>
-          </a:bodyPr>
-          <a:lstStyle/>
-          <a:p>
-            <a:pPr algn="l">
-              <a:defRPr sz="800" b="0">
+            <a:off x="7936992" y="2423160"/>
+            <a:ext cx="1645920" cy="274320"/>
+          </a:xfrm>
+          <a:prstGeom prst="rect">
+            <a:avLst/>
+          </a:prstGeom>
+          <a:noFill/>
+        </p:spPr>
+        <p:txBody>
+          <a:bodyPr wrap="square">
+            <a:spAutoFit/>
+          </a:bodyPr>
+          <a:lstStyle/>
+          <a:p>
+            <a:pPr algn="l">
+              <a:defRPr sz="900" b="0">
                 <a:solidFill>
                   <a:srgbClr val="212121"/>
                 </a:solidFill>
@@ -25578,8 +25578,8 @@
         </p:nvSpPr>
         <p:spPr>
           <a:xfrm>
-            <a:off x="6720840" y="2404872"/>
-            <a:ext cx="1188720" cy="329184"/>
+            <a:off x="9692640" y="2404872"/>
+            <a:ext cx="1783080" cy="329184"/>
           </a:xfrm>
           <a:prstGeom prst="rect">
             <a:avLst/>
@@ -25621,22 +25621,22 @@
         </p:nvSpPr>
         <p:spPr>
           <a:xfrm>
-            <a:off x="6766559" y="2423160"/>
-            <a:ext cx="1097280" cy="274320"/>
-          </a:xfrm>
-          <a:prstGeom prst="rect">
-            <a:avLst/>
-          </a:prstGeom>
-          <a:noFill/>
-        </p:spPr>
-        <p:txBody>
-          <a:bodyPr wrap="square">
-            <a:spAutoFit/>
-          </a:bodyPr>
-          <a:lstStyle/>
-          <a:p>
-            <a:pPr algn="l">
-              <a:defRPr sz="800" b="0">
+            <a:off x="9765792" y="2423160"/>
+            <a:ext cx="1645920" cy="274320"/>
+          </a:xfrm>
+          <a:prstGeom prst="rect">
+            <a:avLst/>
+          </a:prstGeom>
+          <a:noFill/>
+        </p:spPr>
+        <p:txBody>
+          <a:bodyPr wrap="square">
+            <a:spAutoFit/>
+          </a:bodyPr>
+          <a:lstStyle/>
+          <a:p>
+            <a:pPr algn="l">
+              <a:defRPr sz="900" b="0">
                 <a:solidFill>
                   <a:srgbClr val="212121"/>
                 </a:solidFill>
@@ -25658,7 +25658,7 @@
         <p:spPr>
           <a:xfrm>
             <a:off x="548640" y="2752344"/>
-            <a:ext cx="1188720" cy="329184"/>
+            <a:ext cx="1783080" cy="329184"/>
           </a:xfrm>
           <a:prstGeom prst="rect">
             <a:avLst/>
@@ -25700,22 +25700,22 @@
         </p:nvSpPr>
         <p:spPr>
           <a:xfrm>
-            <a:off x="594360" y="2770632"/>
-            <a:ext cx="1097280" cy="274320"/>
-          </a:xfrm>
-          <a:prstGeom prst="rect">
-            <a:avLst/>
-          </a:prstGeom>
-          <a:noFill/>
-        </p:spPr>
-        <p:txBody>
-          <a:bodyPr wrap="square">
-            <a:spAutoFit/>
-          </a:bodyPr>
-          <a:lstStyle/>
-          <a:p>
-            <a:pPr algn="l">
-              <a:defRPr sz="800" b="0">
+            <a:off x="621792" y="2770632"/>
+            <a:ext cx="1645920" cy="274320"/>
+          </a:xfrm>
+          <a:prstGeom prst="rect">
+            <a:avLst/>
+          </a:prstGeom>
+          <a:noFill/>
+        </p:spPr>
+        <p:txBody>
+          <a:bodyPr wrap="square">
+            <a:spAutoFit/>
+          </a:bodyPr>
+          <a:lstStyle/>
+          <a:p>
+            <a:pPr algn="l">
+              <a:defRPr sz="900" b="0">
                 <a:solidFill>
                   <a:srgbClr val="212121"/>
                 </a:solidFill>
@@ -25736,8 +25736,8 @@
         </p:nvSpPr>
         <p:spPr>
           <a:xfrm>
-            <a:off x="1783080" y="2752344"/>
-            <a:ext cx="1188720" cy="329184"/>
+            <a:off x="2377440" y="2752344"/>
+            <a:ext cx="1783080" cy="329184"/>
           </a:xfrm>
           <a:prstGeom prst="rect">
             <a:avLst/>
@@ -25779,22 +25779,22 @@
         </p:nvSpPr>
         <p:spPr>
           <a:xfrm>
-            <a:off x="1828800" y="2770632"/>
-            <a:ext cx="1097280" cy="274320"/>
-          </a:xfrm>
-          <a:prstGeom prst="rect">
-            <a:avLst/>
-          </a:prstGeom>
-          <a:noFill/>
-        </p:spPr>
-        <p:txBody>
-          <a:bodyPr wrap="square">
-            <a:spAutoFit/>
-          </a:bodyPr>
-          <a:lstStyle/>
-          <a:p>
-            <a:pPr algn="l">
-              <a:defRPr sz="800" b="0">
+            <a:off x="2450592" y="2770632"/>
+            <a:ext cx="1645920" cy="274320"/>
+          </a:xfrm>
+          <a:prstGeom prst="rect">
+            <a:avLst/>
+          </a:prstGeom>
+          <a:noFill/>
+        </p:spPr>
+        <p:txBody>
+          <a:bodyPr wrap="square">
+            <a:spAutoFit/>
+          </a:bodyPr>
+          <a:lstStyle/>
+          <a:p>
+            <a:pPr algn="l">
+              <a:defRPr sz="900" b="0">
                 <a:solidFill>
                   <a:srgbClr val="212121"/>
                 </a:solidFill>
@@ -25815,8 +25815,8 @@
         </p:nvSpPr>
         <p:spPr>
           <a:xfrm>
-            <a:off x="3017520" y="2752344"/>
-            <a:ext cx="1188720" cy="329184"/>
+            <a:off x="4206240" y="2752344"/>
+            <a:ext cx="1783080" cy="329184"/>
           </a:xfrm>
           <a:prstGeom prst="rect">
             <a:avLst/>
@@ -25858,22 +25858,22 @@
         </p:nvSpPr>
         <p:spPr>
           <a:xfrm>
-            <a:off x="3063240" y="2770632"/>
-            <a:ext cx="1097280" cy="274320"/>
-          </a:xfrm>
-          <a:prstGeom prst="rect">
-            <a:avLst/>
-          </a:prstGeom>
-          <a:noFill/>
-        </p:spPr>
-        <p:txBody>
-          <a:bodyPr wrap="square">
-            <a:spAutoFit/>
-          </a:bodyPr>
-          <a:lstStyle/>
-          <a:p>
-            <a:pPr algn="l">
-              <a:defRPr sz="800" b="0">
+            <a:off x="4279392" y="2770632"/>
+            <a:ext cx="1645920" cy="274320"/>
+          </a:xfrm>
+          <a:prstGeom prst="rect">
+            <a:avLst/>
+          </a:prstGeom>
+          <a:noFill/>
+        </p:spPr>
+        <p:txBody>
+          <a:bodyPr wrap="square">
+            <a:spAutoFit/>
+          </a:bodyPr>
+          <a:lstStyle/>
+          <a:p>
+            <a:pPr algn="l">
+              <a:defRPr sz="900" b="0">
                 <a:solidFill>
                   <a:srgbClr val="212121"/>
                 </a:solidFill>
@@ -25894,8 +25894,8 @@
         </p:nvSpPr>
         <p:spPr>
           <a:xfrm>
-            <a:off x="4251960" y="2752344"/>
-            <a:ext cx="1188720" cy="329184"/>
+            <a:off x="6035040" y="2752344"/>
+            <a:ext cx="1783080" cy="329184"/>
           </a:xfrm>
           <a:prstGeom prst="rect">
             <a:avLst/>
@@ -25937,22 +25937,22 @@
         </p:nvSpPr>
         <p:spPr>
           <a:xfrm>
-            <a:off x="4297680" y="2770632"/>
-            <a:ext cx="1097280" cy="274320"/>
-          </a:xfrm>
-          <a:prstGeom prst="rect">
-            <a:avLst/>
-          </a:prstGeom>
-          <a:noFill/>
-        </p:spPr>
-        <p:txBody>
-          <a:bodyPr wrap="square">
-            <a:spAutoFit/>
-          </a:bodyPr>
-          <a:lstStyle/>
-          <a:p>
-            <a:pPr algn="l">
-              <a:defRPr sz="800" b="0">
+            <a:off x="6108192" y="2770632"/>
+            <a:ext cx="1645920" cy="274320"/>
+          </a:xfrm>
+          <a:prstGeom prst="rect">
+            <a:avLst/>
+          </a:prstGeom>
+          <a:noFill/>
+        </p:spPr>
+        <p:txBody>
+          <a:bodyPr wrap="square">
+            <a:spAutoFit/>
+          </a:bodyPr>
+          <a:lstStyle/>
+          <a:p>
+            <a:pPr algn="l">
+              <a:defRPr sz="900" b="0">
                 <a:solidFill>
                   <a:srgbClr val="212121"/>
                 </a:solidFill>
@@ -25973,8 +25973,8 @@
         </p:nvSpPr>
         <p:spPr>
           <a:xfrm>
-            <a:off x="5486400" y="2752344"/>
-            <a:ext cx="1188720" cy="329184"/>
+            <a:off x="7863840" y="2752344"/>
+            <a:ext cx="1783080" cy="329184"/>
           </a:xfrm>
           <a:prstGeom prst="rect">
             <a:avLst/>
@@ -26016,22 +26016,22 @@
         </p:nvSpPr>
         <p:spPr>
           <a:xfrm>
-            <a:off x="5532120" y="2770632"/>
-            <a:ext cx="1097280" cy="274320"/>
-          </a:xfrm>
-          <a:prstGeom prst="rect">
-            <a:avLst/>
-          </a:prstGeom>
-          <a:noFill/>
-        </p:spPr>
-        <p:txBody>
-          <a:bodyPr wrap="square">
-            <a:spAutoFit/>
-          </a:bodyPr>
-          <a:lstStyle/>
-          <a:p>
-            <a:pPr algn="l">
-              <a:defRPr sz="800" b="0">
+            <a:off x="7936992" y="2770632"/>
+            <a:ext cx="1645920" cy="274320"/>
+          </a:xfrm>
+          <a:prstGeom prst="rect">
+            <a:avLst/>
+          </a:prstGeom>
+          <a:noFill/>
+        </p:spPr>
+        <p:txBody>
+          <a:bodyPr wrap="square">
+            <a:spAutoFit/>
+          </a:bodyPr>
+          <a:lstStyle/>
+          <a:p>
+            <a:pPr algn="l">
+              <a:defRPr sz="900" b="0">
                 <a:solidFill>
                   <a:srgbClr val="212121"/>
                 </a:solidFill>
@@ -26052,8 +26052,8 @@
         </p:nvSpPr>
         <p:spPr>
           <a:xfrm>
-            <a:off x="6720840" y="2752344"/>
-            <a:ext cx="1188720" cy="329184"/>
+            <a:off x="9692640" y="2752344"/>
+            <a:ext cx="1783080" cy="329184"/>
           </a:xfrm>
           <a:prstGeom prst="rect">
             <a:avLst/>
@@ -26095,22 +26095,22 @@
         </p:nvSpPr>
         <p:spPr>
           <a:xfrm>
-            <a:off x="6766559" y="2770632"/>
-            <a:ext cx="1097280" cy="274320"/>
-          </a:xfrm>
-          <a:prstGeom prst="rect">
-            <a:avLst/>
-          </a:prstGeom>
-          <a:noFill/>
-        </p:spPr>
-        <p:txBody>
-          <a:bodyPr wrap="square">
-            <a:spAutoFit/>
-          </a:bodyPr>
-          <a:lstStyle/>
-          <a:p>
-            <a:pPr algn="l">
-              <a:defRPr sz="800" b="0">
+            <a:off x="9765792" y="2770632"/>
+            <a:ext cx="1645920" cy="274320"/>
+          </a:xfrm>
+          <a:prstGeom prst="rect">
+            <a:avLst/>
+          </a:prstGeom>
+          <a:noFill/>
+        </p:spPr>
+        <p:txBody>
+          <a:bodyPr wrap="square">
+            <a:spAutoFit/>
+          </a:bodyPr>
+          <a:lstStyle/>
+          <a:p>
+            <a:pPr algn="l">
+              <a:defRPr sz="900" b="0">
                 <a:solidFill>
                   <a:srgbClr val="212121"/>
                 </a:solidFill>
@@ -26132,7 +26132,7 @@
         <p:spPr>
           <a:xfrm>
             <a:off x="548640" y="3099816"/>
-            <a:ext cx="1188720" cy="329184"/>
+            <a:ext cx="1783080" cy="329184"/>
           </a:xfrm>
           <a:prstGeom prst="rect">
             <a:avLst/>
@@ -26174,22 +26174,22 @@
         </p:nvSpPr>
         <p:spPr>
           <a:xfrm>
-            <a:off x="594360" y="3118104"/>
-            <a:ext cx="1097280" cy="274320"/>
-          </a:xfrm>
-          <a:prstGeom prst="rect">
-            <a:avLst/>
-          </a:prstGeom>
-          <a:noFill/>
-        </p:spPr>
-        <p:txBody>
-          <a:bodyPr wrap="square">
-            <a:spAutoFit/>
-          </a:bodyPr>
-          <a:lstStyle/>
-          <a:p>
-            <a:pPr algn="l">
-              <a:defRPr sz="800" b="1">
+            <a:off x="621792" y="3118104"/>
+            <a:ext cx="1645920" cy="274320"/>
+          </a:xfrm>
+          <a:prstGeom prst="rect">
+            <a:avLst/>
+          </a:prstGeom>
+          <a:noFill/>
+        </p:spPr>
+        <p:txBody>
+          <a:bodyPr wrap="square">
+            <a:spAutoFit/>
+          </a:bodyPr>
+          <a:lstStyle/>
+          <a:p>
+            <a:pPr algn="l">
+              <a:defRPr sz="900" b="1">
                 <a:solidFill>
                   <a:srgbClr val="FFFFFF"/>
                 </a:solidFill>
@@ -26210,8 +26210,8 @@
         </p:nvSpPr>
         <p:spPr>
           <a:xfrm>
-            <a:off x="1783080" y="3099816"/>
-            <a:ext cx="1188720" cy="329184"/>
+            <a:off x="2377440" y="3099816"/>
+            <a:ext cx="1783080" cy="329184"/>
           </a:xfrm>
           <a:prstGeom prst="rect">
             <a:avLst/>
@@ -26253,22 +26253,22 @@
         </p:nvSpPr>
         <p:spPr>
           <a:xfrm>
-            <a:off x="1828800" y="3118104"/>
-            <a:ext cx="1097280" cy="274320"/>
-          </a:xfrm>
-          <a:prstGeom prst="rect">
-            <a:avLst/>
-          </a:prstGeom>
-          <a:noFill/>
-        </p:spPr>
-        <p:txBody>
-          <a:bodyPr wrap="square">
-            <a:spAutoFit/>
-          </a:bodyPr>
-          <a:lstStyle/>
-          <a:p>
-            <a:pPr algn="l">
-              <a:defRPr sz="800" b="1">
+            <a:off x="2450592" y="3118104"/>
+            <a:ext cx="1645920" cy="274320"/>
+          </a:xfrm>
+          <a:prstGeom prst="rect">
+            <a:avLst/>
+          </a:prstGeom>
+          <a:noFill/>
+        </p:spPr>
+        <p:txBody>
+          <a:bodyPr wrap="square">
+            <a:spAutoFit/>
+          </a:bodyPr>
+          <a:lstStyle/>
+          <a:p>
+            <a:pPr algn="l">
+              <a:defRPr sz="900" b="1">
                 <a:solidFill>
                   <a:srgbClr val="FFFFFF"/>
                 </a:solidFill>
@@ -26289,8 +26289,8 @@
         </p:nvSpPr>
         <p:spPr>
           <a:xfrm>
-            <a:off x="3017520" y="3099816"/>
-            <a:ext cx="1188720" cy="329184"/>
+            <a:off x="4206240" y="3099816"/>
+            <a:ext cx="1783080" cy="329184"/>
           </a:xfrm>
           <a:prstGeom prst="rect">
             <a:avLst/>
@@ -26332,22 +26332,22 @@
         </p:nvSpPr>
         <p:spPr>
           <a:xfrm>
-            <a:off x="3063240" y="3118104"/>
-            <a:ext cx="1097280" cy="274320"/>
-          </a:xfrm>
-          <a:prstGeom prst="rect">
-            <a:avLst/>
-          </a:prstGeom>
-          <a:noFill/>
-        </p:spPr>
-        <p:txBody>
-          <a:bodyPr wrap="square">
-            <a:spAutoFit/>
-          </a:bodyPr>
-          <a:lstStyle/>
-          <a:p>
-            <a:pPr algn="l">
-              <a:defRPr sz="800" b="1">
+            <a:off x="4279392" y="3118104"/>
+            <a:ext cx="1645920" cy="274320"/>
+          </a:xfrm>
+          <a:prstGeom prst="rect">
+            <a:avLst/>
+          </a:prstGeom>
+          <a:noFill/>
+        </p:spPr>
+        <p:txBody>
+          <a:bodyPr wrap="square">
+            <a:spAutoFit/>
+          </a:bodyPr>
+          <a:lstStyle/>
+          <a:p>
+            <a:pPr algn="l">
+              <a:defRPr sz="900" b="1">
                 <a:solidFill>
                   <a:srgbClr val="FFFFFF"/>
                 </a:solidFill>
@@ -26368,8 +26368,8 @@
         </p:nvSpPr>
         <p:spPr>
           <a:xfrm>
-            <a:off x="4251960" y="3099816"/>
-            <a:ext cx="1188720" cy="329184"/>
+            <a:off x="6035040" y="3099816"/>
+            <a:ext cx="1783080" cy="329184"/>
           </a:xfrm>
           <a:prstGeom prst="rect">
             <a:avLst/>
@@ -26411,22 +26411,22 @@
         </p:nvSpPr>
         <p:spPr>
           <a:xfrm>
-            <a:off x="4297680" y="3118104"/>
-            <a:ext cx="1097280" cy="274320"/>
-          </a:xfrm>
-          <a:prstGeom prst="rect">
-            <a:avLst/>
-          </a:prstGeom>
-          <a:noFill/>
-        </p:spPr>
-        <p:txBody>
-          <a:bodyPr wrap="square">
-            <a:spAutoFit/>
-          </a:bodyPr>
-          <a:lstStyle/>
-          <a:p>
-            <a:pPr algn="l">
-              <a:defRPr sz="800" b="1">
+            <a:off x="6108192" y="3118104"/>
+            <a:ext cx="1645920" cy="274320"/>
+          </a:xfrm>
+          <a:prstGeom prst="rect">
+            <a:avLst/>
+          </a:prstGeom>
+          <a:noFill/>
+        </p:spPr>
+        <p:txBody>
+          <a:bodyPr wrap="square">
+            <a:spAutoFit/>
+          </a:bodyPr>
+          <a:lstStyle/>
+          <a:p>
+            <a:pPr algn="l">
+              <a:defRPr sz="900" b="1">
                 <a:solidFill>
                   <a:srgbClr val="FFFFFF"/>
                 </a:solidFill>
@@ -26447,8 +26447,8 @@
         </p:nvSpPr>
         <p:spPr>
           <a:xfrm>
-            <a:off x="5486400" y="3099816"/>
-            <a:ext cx="1188720" cy="329184"/>
+            <a:off x="7863840" y="3099816"/>
+            <a:ext cx="1783080" cy="329184"/>
           </a:xfrm>
           <a:prstGeom prst="rect">
             <a:avLst/>
@@ -26490,22 +26490,22 @@
         </p:nvSpPr>
         <p:spPr>
           <a:xfrm>
-            <a:off x="5532120" y="3118104"/>
-            <a:ext cx="1097280" cy="274320"/>
-          </a:xfrm>
-          <a:prstGeom prst="rect">
-            <a:avLst/>
-          </a:prstGeom>
-          <a:noFill/>
-        </p:spPr>
-        <p:txBody>
-          <a:bodyPr wrap="square">
-            <a:spAutoFit/>
-          </a:bodyPr>
-          <a:lstStyle/>
-          <a:p>
-            <a:pPr algn="l">
-              <a:defRPr sz="800" b="1">
+            <a:off x="7936992" y="3118104"/>
+            <a:ext cx="1645920" cy="274320"/>
+          </a:xfrm>
+          <a:prstGeom prst="rect">
+            <a:avLst/>
+          </a:prstGeom>
+          <a:noFill/>
+        </p:spPr>
+        <p:txBody>
+          <a:bodyPr wrap="square">
+            <a:spAutoFit/>
+          </a:bodyPr>
+          <a:lstStyle/>
+          <a:p>
+            <a:pPr algn="l">
+              <a:defRPr sz="900" b="1">
                 <a:solidFill>
                   <a:srgbClr val="FFFFFF"/>
                 </a:solidFill>
@@ -26526,8 +26526,8 @@
         </p:nvSpPr>
         <p:spPr>
           <a:xfrm>
-            <a:off x="6720840" y="3099816"/>
-            <a:ext cx="1188720" cy="329184"/>
+            <a:off x="9692640" y="3099816"/>
+            <a:ext cx="1783080" cy="329184"/>
           </a:xfrm>
           <a:prstGeom prst="rect">
             <a:avLst/>
@@ -26569,22 +26569,22 @@
         </p:nvSpPr>
         <p:spPr>
           <a:xfrm>
-            <a:off x="6766559" y="3118104"/>
-            <a:ext cx="1097280" cy="274320"/>
-          </a:xfrm>
-          <a:prstGeom prst="rect">
-            <a:avLst/>
-          </a:prstGeom>
-          <a:noFill/>
-        </p:spPr>
-        <p:txBody>
-          <a:bodyPr wrap="square">
-            <a:spAutoFit/>
-          </a:bodyPr>
-          <a:lstStyle/>
-          <a:p>
-            <a:pPr algn="l">
-              <a:defRPr sz="800" b="1">
+            <a:off x="9765792" y="3118104"/>
+            <a:ext cx="1645920" cy="274320"/>
+          </a:xfrm>
+          <a:prstGeom prst="rect">
+            <a:avLst/>
+          </a:prstGeom>
+          <a:noFill/>
+        </p:spPr>
+        <p:txBody>
+          <a:bodyPr wrap="square">
+            <a:spAutoFit/>
+          </a:bodyPr>
+          <a:lstStyle/>
+          <a:p>
+            <a:pPr algn="l">
+              <a:defRPr sz="900" b="1">
                 <a:solidFill>
                   <a:srgbClr val="FFFFFF"/>
                 </a:solidFill>
@@ -26605,8 +26605,8 @@
         </p:nvSpPr>
         <p:spPr>
           <a:xfrm>
-            <a:off x="8229600" y="1691640"/>
-            <a:ext cx="3657600" cy="274320"/>
+            <a:off x="548640" y="3749039"/>
+            <a:ext cx="4572000" cy="274320"/>
           </a:xfrm>
           <a:prstGeom prst="rect">
             <a:avLst/>
@@ -26628,7 +26628,7 @@
               </a:defRPr>
             </a:pPr>
             <a:r>
-              <a:t>市場規模</a:t>
+              <a:t>市場規模 — TAM / SAM / SOM</a:t>
             </a:r>
           </a:p>
         </p:txBody>
@@ -26641,8 +26641,8 @@
         </p:nvSpPr>
         <p:spPr>
           <a:xfrm>
-            <a:off x="7498079" y="1920239"/>
-            <a:ext cx="4023360" cy="4023360"/>
+            <a:off x="4023360" y="3840480"/>
+            <a:ext cx="3657600" cy="2743200"/>
           </a:xfrm>
           <a:prstGeom prst="ellipse">
             <a:avLst/>
@@ -26686,8 +26686,8 @@
         </p:nvSpPr>
         <p:spPr>
           <a:xfrm>
-            <a:off x="7589520" y="2103120"/>
-            <a:ext cx="1645920" cy="274320"/>
+            <a:off x="4114800" y="4023360"/>
+            <a:ext cx="1371600" cy="228600"/>
           </a:xfrm>
           <a:prstGeom prst="rect">
             <a:avLst/>
@@ -26722,22 +26722,22 @@
         </p:nvSpPr>
         <p:spPr>
           <a:xfrm>
-            <a:off x="7589520" y="2377439"/>
-            <a:ext cx="2011680" cy="274320"/>
-          </a:xfrm>
-          <a:prstGeom prst="rect">
-            <a:avLst/>
-          </a:prstGeom>
-          <a:noFill/>
-        </p:spPr>
-        <p:txBody>
-          <a:bodyPr wrap="square">
-            <a:spAutoFit/>
-          </a:bodyPr>
-          <a:lstStyle/>
-          <a:p>
-            <a:pPr algn="l">
-              <a:defRPr sz="1000" b="0">
+            <a:off x="4114800" y="4251960"/>
+            <a:ext cx="1828800" cy="228600"/>
+          </a:xfrm>
+          <a:prstGeom prst="rect">
+            <a:avLst/>
+          </a:prstGeom>
+          <a:noFill/>
+        </p:spPr>
+        <p:txBody>
+          <a:bodyPr wrap="square">
+            <a:spAutoFit/>
+          </a:bodyPr>
+          <a:lstStyle/>
+          <a:p>
+            <a:pPr algn="l">
+              <a:defRPr sz="1000" b="1">
                 <a:solidFill>
                   <a:srgbClr val="212121"/>
                 </a:solidFill>
@@ -26745,57 +26745,21 @@
               </a:defRPr>
             </a:pPr>
             <a:r>
-              <a:t>1,250機関</a:t>
-            </a:r>
-          </a:p>
-        </p:txBody>
-      </p:sp>
-      <p:sp>
-        <p:nvSpPr>
-          <p:cNvPr id="71" name="TextBox 70"/>
-          <p:cNvSpPr txBox="1"/>
-          <p:nvPr/>
-        </p:nvSpPr>
-        <p:spPr>
-          <a:xfrm>
-            <a:off x="7589520" y="2651760"/>
-            <a:ext cx="2011680" cy="274320"/>
-          </a:xfrm>
-          <a:prstGeom prst="rect">
-            <a:avLst/>
-          </a:prstGeom>
-          <a:noFill/>
-        </p:spPr>
-        <p:txBody>
-          <a:bodyPr wrap="square">
-            <a:spAutoFit/>
-          </a:bodyPr>
-          <a:lstStyle/>
-          <a:p>
-            <a:pPr algn="l">
-              <a:defRPr sz="1200" b="1">
-                <a:solidFill>
-                  <a:srgbClr val="212121"/>
-                </a:solidFill>
-                <a:latin typeface="Meiryo"/>
-              </a:defRPr>
-            </a:pPr>
-            <a:r>
-              <a:t>225億円</a:t>
-            </a:r>
-          </a:p>
-        </p:txBody>
-      </p:sp>
-      <p:sp>
-        <p:nvSpPr>
-          <p:cNvPr id="72" name="Oval 71"/>
+              <a:t>1,250機関 · 225億円</a:t>
+            </a:r>
+          </a:p>
+        </p:txBody>
+      </p:sp>
+      <p:sp>
+        <p:nvSpPr>
+          <p:cNvPr id="71" name="Oval 70"/>
           <p:cNvSpPr/>
           <p:nvPr/>
         </p:nvSpPr>
         <p:spPr>
           <a:xfrm>
-            <a:off x="8138160" y="2560320"/>
-            <a:ext cx="2743200" cy="2743200"/>
+            <a:off x="4663440" y="4297680"/>
+            <a:ext cx="2377440" cy="1828800"/>
           </a:xfrm>
           <a:prstGeom prst="ellipse">
             <a:avLst/>
@@ -26833,64 +26797,64 @@
       </p:sp>
       <p:sp>
         <p:nvSpPr>
+          <p:cNvPr id="72" name="TextBox 71"/>
+          <p:cNvSpPr txBox="1"/>
+          <p:nvPr/>
+        </p:nvSpPr>
+        <p:spPr>
+          <a:xfrm>
+            <a:off x="6035040" y="4434840"/>
+            <a:ext cx="1371600" cy="228600"/>
+          </a:xfrm>
+          <a:prstGeom prst="rect">
+            <a:avLst/>
+          </a:prstGeom>
+          <a:noFill/>
+        </p:spPr>
+        <p:txBody>
+          <a:bodyPr wrap="square">
+            <a:spAutoFit/>
+          </a:bodyPr>
+          <a:lstStyle/>
+          <a:p>
+            <a:pPr algn="l">
+              <a:defRPr sz="900" b="1">
+                <a:solidFill>
+                  <a:srgbClr val="00BCD4"/>
+                </a:solidFill>
+                <a:latin typeface="Meiryo"/>
+              </a:defRPr>
+            </a:pPr>
+            <a:r>
+              <a:t>S A M</a:t>
+            </a:r>
+          </a:p>
+        </p:txBody>
+      </p:sp>
+      <p:sp>
+        <p:nvSpPr>
           <p:cNvPr id="73" name="TextBox 72"/>
           <p:cNvSpPr txBox="1"/>
           <p:nvPr/>
         </p:nvSpPr>
         <p:spPr>
           <a:xfrm>
-            <a:off x="9784080" y="2743200"/>
-            <a:ext cx="1645920" cy="274320"/>
-          </a:xfrm>
-          <a:prstGeom prst="rect">
-            <a:avLst/>
-          </a:prstGeom>
-          <a:noFill/>
-        </p:spPr>
-        <p:txBody>
-          <a:bodyPr wrap="square">
-            <a:spAutoFit/>
-          </a:bodyPr>
-          <a:lstStyle/>
-          <a:p>
-            <a:pPr algn="l">
-              <a:defRPr sz="900" b="1">
-                <a:solidFill>
-                  <a:srgbClr val="00BCD4"/>
-                </a:solidFill>
-                <a:latin typeface="Meiryo"/>
-              </a:defRPr>
-            </a:pPr>
-            <a:r>
-              <a:t>S A M</a:t>
-            </a:r>
-          </a:p>
-        </p:txBody>
-      </p:sp>
-      <p:sp>
-        <p:nvSpPr>
-          <p:cNvPr id="74" name="TextBox 73"/>
-          <p:cNvSpPr txBox="1"/>
-          <p:nvPr/>
-        </p:nvSpPr>
-        <p:spPr>
-          <a:xfrm>
-            <a:off x="9784080" y="3017520"/>
-            <a:ext cx="1371600" cy="274320"/>
-          </a:xfrm>
-          <a:prstGeom prst="rect">
-            <a:avLst/>
-          </a:prstGeom>
-          <a:noFill/>
-        </p:spPr>
-        <p:txBody>
-          <a:bodyPr wrap="square">
-            <a:spAutoFit/>
-          </a:bodyPr>
-          <a:lstStyle/>
-          <a:p>
-            <a:pPr algn="l">
-              <a:defRPr sz="1000" b="0">
+            <a:off x="6035040" y="4663440"/>
+            <a:ext cx="1371600" cy="228600"/>
+          </a:xfrm>
+          <a:prstGeom prst="rect">
+            <a:avLst/>
+          </a:prstGeom>
+          <a:noFill/>
+        </p:spPr>
+        <p:txBody>
+          <a:bodyPr wrap="square">
+            <a:spAutoFit/>
+          </a:bodyPr>
+          <a:lstStyle/>
+          <a:p>
+            <a:pPr algn="l">
+              <a:defRPr sz="1000" b="1">
                 <a:solidFill>
                   <a:srgbClr val="212121"/>
                 </a:solidFill>
@@ -26898,57 +26862,21 @@
               </a:defRPr>
             </a:pPr>
             <a:r>
-              <a:t>650機関</a:t>
-            </a:r>
-          </a:p>
-        </p:txBody>
-      </p:sp>
-      <p:sp>
-        <p:nvSpPr>
-          <p:cNvPr id="75" name="TextBox 74"/>
-          <p:cNvSpPr txBox="1"/>
-          <p:nvPr/>
-        </p:nvSpPr>
-        <p:spPr>
-          <a:xfrm>
-            <a:off x="9784080" y="3291839"/>
-            <a:ext cx="1371600" cy="274320"/>
-          </a:xfrm>
-          <a:prstGeom prst="rect">
-            <a:avLst/>
-          </a:prstGeom>
-          <a:noFill/>
-        </p:spPr>
-        <p:txBody>
-          <a:bodyPr wrap="square">
-            <a:spAutoFit/>
-          </a:bodyPr>
-          <a:lstStyle/>
-          <a:p>
-            <a:pPr algn="l">
-              <a:defRPr sz="1200" b="1">
-                <a:solidFill>
-                  <a:srgbClr val="212121"/>
-                </a:solidFill>
-                <a:latin typeface="Meiryo"/>
-              </a:defRPr>
-            </a:pPr>
-            <a:r>
-              <a:t>117億円</a:t>
-            </a:r>
-          </a:p>
-        </p:txBody>
-      </p:sp>
-      <p:sp>
-        <p:nvSpPr>
-          <p:cNvPr id="76" name="Oval 75"/>
+              <a:t>650機関 · 117億円</a:t>
+            </a:r>
+          </a:p>
+        </p:txBody>
+      </p:sp>
+      <p:sp>
+        <p:nvSpPr>
+          <p:cNvPr id="74" name="Oval 73"/>
           <p:cNvSpPr/>
           <p:nvPr/>
         </p:nvSpPr>
         <p:spPr>
           <a:xfrm>
-            <a:off x="8869680" y="3291839"/>
-            <a:ext cx="1280160" cy="1280160"/>
+            <a:off x="5166360" y="4709160"/>
+            <a:ext cx="1371600" cy="1005840"/>
           </a:xfrm>
           <a:prstGeom prst="ellipse">
             <a:avLst/>
@@ -26984,14 +26912,14 @@
       </p:sp>
       <p:sp>
         <p:nvSpPr>
-          <p:cNvPr id="77" name="TextBox 76"/>
-          <p:cNvSpPr txBox="1"/>
-          <p:nvPr/>
-        </p:nvSpPr>
-        <p:spPr>
-          <a:xfrm>
-            <a:off x="8961120" y="3611879"/>
-            <a:ext cx="1097280" cy="228600"/>
+          <p:cNvPr id="75" name="TextBox 74"/>
+          <p:cNvSpPr txBox="1"/>
+          <p:nvPr/>
+        </p:nvSpPr>
+        <p:spPr>
+          <a:xfrm>
+            <a:off x="5212080" y="4846320"/>
+            <a:ext cx="1280160" cy="228600"/>
           </a:xfrm>
           <a:prstGeom prst="rect">
             <a:avLst/>
@@ -27020,14 +26948,14 @@
       </p:sp>
       <p:sp>
         <p:nvSpPr>
-          <p:cNvPr id="78" name="TextBox 77"/>
-          <p:cNvSpPr txBox="1"/>
-          <p:nvPr/>
-        </p:nvSpPr>
-        <p:spPr>
-          <a:xfrm>
-            <a:off x="8961120" y="3840480"/>
-            <a:ext cx="1097280" cy="228600"/>
+          <p:cNvPr id="76" name="TextBox 75"/>
+          <p:cNvSpPr txBox="1"/>
+          <p:nvPr/>
+        </p:nvSpPr>
+        <p:spPr>
+          <a:xfrm>
+            <a:off x="5212080" y="5074920"/>
+            <a:ext cx="1280160" cy="228600"/>
           </a:xfrm>
           <a:prstGeom prst="rect">
             <a:avLst/>
@@ -27041,7 +26969,7 @@
           <a:lstStyle/>
           <a:p>
             <a:pPr algn="ctr">
-              <a:defRPr sz="900" b="0">
+              <a:defRPr sz="900" b="1">
                 <a:solidFill>
                   <a:srgbClr val="FFFFFF"/>
                 </a:solidFill>
@@ -27049,43 +26977,7 @@
               </a:defRPr>
             </a:pPr>
             <a:r>
-              <a:t>100機関</a:t>
-            </a:r>
-          </a:p>
-        </p:txBody>
-      </p:sp>
-      <p:sp>
-        <p:nvSpPr>
-          <p:cNvPr id="79" name="TextBox 78"/>
-          <p:cNvSpPr txBox="1"/>
-          <p:nvPr/>
-        </p:nvSpPr>
-        <p:spPr>
-          <a:xfrm>
-            <a:off x="8961120" y="4069080"/>
-            <a:ext cx="1097280" cy="274320"/>
-          </a:xfrm>
-          <a:prstGeom prst="rect">
-            <a:avLst/>
-          </a:prstGeom>
-          <a:noFill/>
-        </p:spPr>
-        <p:txBody>
-          <a:bodyPr wrap="square">
-            <a:spAutoFit/>
-          </a:bodyPr>
-          <a:lstStyle/>
-          <a:p>
-            <a:pPr algn="ctr">
-              <a:defRPr sz="1100" b="1">
-                <a:solidFill>
-                  <a:srgbClr val="FFFFFF"/>
-                </a:solidFill>
-                <a:latin typeface="Meiryo"/>
-              </a:defRPr>
-            </a:pPr>
-            <a:r>
-              <a:t>18億円</a:t>
+              <a:t>100機関 · 18億円</a:t>
             </a:r>
           </a:p>
         </p:txBody>

</xml_diff>

<commit_message>
fix: Slide 9 SAM label moved to avoid SOM circle overlap
Co-Authored-By: Claude Opus 4.6 (1M context) <noreply@anthropic.com>
</commit_message>
<xml_diff>
--- a/assets/TAROS_Investor_Pitch_Revised.pptx
+++ b/assets/TAROS_Investor_Pitch_Revised.pptx
@@ -26803,7 +26803,7 @@
         </p:nvSpPr>
         <p:spPr>
           <a:xfrm>
-            <a:off x="6035040" y="4434840"/>
+            <a:off x="6492240" y="4343400"/>
             <a:ext cx="1371600" cy="228600"/>
           </a:xfrm>
           <a:prstGeom prst="rect">
@@ -26839,8 +26839,8 @@
         </p:nvSpPr>
         <p:spPr>
           <a:xfrm>
-            <a:off x="6035040" y="4663440"/>
-            <a:ext cx="1371600" cy="228600"/>
+            <a:off x="6492240" y="4572000"/>
+            <a:ext cx="1645920" cy="228600"/>
           </a:xfrm>
           <a:prstGeom prst="rect">
             <a:avLst/>

</xml_diff>

<commit_message>
fix: Slide 5 chevron text visibility + Slide 6 threshold bar dB labels
- Slide 5: Chevron desc TEXT_LIGHT→TEXT_WHITE (was invisible on cyan bg)
- Slide 6: "7.5 dB" label moved left (was overflowing purple bar edge)
- Slide 6: "9.3 dB" label moved left (same overflow issue on green bar)

Co-Authored-By: Claude Opus 4.6 (1M context) <noreply@anthropic.com>
</commit_message>
<xml_diff>
--- a/assets/TAROS_Investor_Pitch_Revised.pptx
+++ b/assets/TAROS_Investor_Pitch_Revised.pptx
@@ -18603,7 +18603,7 @@
             <a:pPr algn="ctr">
               <a:defRPr sz="1000" b="0">
                 <a:solidFill>
-                  <a:srgbClr val="B0BEC5"/>
+                  <a:srgbClr val="FFFFFF"/>
                 </a:solidFill>
                 <a:latin typeface="Meiryo"/>
               </a:defRPr>
@@ -21188,7 +21188,7 @@
         </p:nvSpPr>
         <p:spPr>
           <a:xfrm>
-            <a:off x="8412480" y="4315968"/>
+            <a:off x="7498079" y="4315968"/>
             <a:ext cx="1371600" cy="365760"/>
           </a:xfrm>
           <a:prstGeom prst="rect">
@@ -21303,7 +21303,7 @@
         </p:nvSpPr>
         <p:spPr>
           <a:xfrm>
-            <a:off x="6217920" y="4818888"/>
+            <a:off x="5303520" y="4818888"/>
             <a:ext cx="1371600" cy="365760"/>
           </a:xfrm>
           <a:prstGeom prst="rect">

</xml_diff>

<commit_message>
fix(R10): 4-team review — 4 Critical + 5 Major fixes across 8 slides
Critical:
- Slide 12: DV-FBQC weight 28kg → system 51kg (本体28kg+冷却23kg)
- Slide 12: "81-90%" mixed metrics → unified "81%" with Level A/B disclosure
- Slide 14: Remove misleading "リスク調整後リターン ~3.5倍" (ARR≠profit)
- Color: Add GREEN_FILL (#2E7D32) for white-on-green contrast (WCAG)

Major:
- Slide 1: 109W (Pro only) → 104-112W (all products match price range)
- Slide 4: Noh-Chamberland "確定" → "報告" (overstatement correction)
- Slide 8: FLAGSHIP badge TEXT_WHITE → TEXT_DARK (contrast fix)
- Slide 6: Chain descriptions 9pt → 10pt (readability on ACCENT bg)
- Slide 13: TEXT_LIGHT on ACCENT → TEXT_WHITE (1.5:1 → 2.6:1 contrast)

Co-Authored-By: Claude Opus 4.6 (1M context) <noreply@anthropic.com>
</commit_message>
<xml_diff>
--- a/assets/TAROS_Investor_Pitch_Revised.pptx
+++ b/assets/TAROS_Investor_Pitch_Revised.pptx
@@ -3330,7 +3330,7 @@
               </a:defRPr>
             </a:pPr>
             <a:r>
-              <a:t>7-in-1 Quantum Platform  |  完全室温・109W  |  1,350万〜2,550万円</a:t>
+              <a:t>7-in-1 Quantum Platform  |  完全室温・104-112W  |  1,350万〜2,550万円</a:t>
             </a:r>
           </a:p>
         </p:txBody>
@@ -3714,7 +3714,7 @@
             <a:avLst/>
           </a:prstGeom>
           <a:solidFill>
-            <a:srgbClr val="66BB6A"/>
+            <a:srgbClr val="2E7D32"/>
           </a:solidFill>
           <a:ln>
             <a:noFill/>
@@ -3987,7 +3987,7 @@
             <a:avLst/>
           </a:prstGeom>
           <a:solidFill>
-            <a:srgbClr val="66BB6A"/>
+            <a:srgbClr val="2E7D32"/>
           </a:solidFill>
           <a:ln>
             <a:noFill/>
@@ -4109,7 +4109,7 @@
             <a:avLst/>
           </a:prstGeom>
           <a:solidFill>
-            <a:srgbClr val="66BB6A"/>
+            <a:srgbClr val="2E7D32"/>
           </a:solidFill>
           <a:ln>
             <a:noFill/>
@@ -4382,7 +4382,7 @@
             <a:avLst/>
           </a:prstGeom>
           <a:solidFill>
-            <a:srgbClr val="66BB6A"/>
+            <a:srgbClr val="2E7D32"/>
           </a:solidFill>
           <a:ln>
             <a:noFill/>
@@ -4504,7 +4504,7 @@
             <a:avLst/>
           </a:prstGeom>
           <a:solidFill>
-            <a:srgbClr val="66BB6A"/>
+            <a:srgbClr val="2E7D32"/>
           </a:solidFill>
           <a:ln>
             <a:noFill/>
@@ -4777,7 +4777,7 @@
             <a:avLst/>
           </a:prstGeom>
           <a:solidFill>
-            <a:srgbClr val="66BB6A"/>
+            <a:srgbClr val="2E7D32"/>
           </a:solidFill>
           <a:ln>
             <a:noFill/>
@@ -4899,7 +4899,7 @@
             <a:avLst/>
           </a:prstGeom>
           <a:solidFill>
-            <a:srgbClr val="66BB6A"/>
+            <a:srgbClr val="2E7D32"/>
           </a:solidFill>
           <a:ln>
             <a:noFill/>
@@ -5172,7 +5172,7 @@
             <a:avLst/>
           </a:prstGeom>
           <a:solidFill>
-            <a:srgbClr val="66BB6A"/>
+            <a:srgbClr val="2E7D32"/>
           </a:solidFill>
           <a:ln>
             <a:noFill/>
@@ -7229,7 +7229,7 @@
             <a:avLst/>
           </a:prstGeom>
           <a:solidFill>
-            <a:srgbClr val="66BB6A"/>
+            <a:srgbClr val="2E7D32"/>
           </a:solidFill>
           <a:ln>
             <a:noFill/>
@@ -7323,7 +7323,7 @@
           <a:lstStyle/>
           <a:p>
             <a:pPr algn="ctr">
-              <a:defRPr sz="2200" b="1">
+              <a:defRPr sz="2600" b="1">
                 <a:solidFill>
                   <a:srgbClr val="66BB6A"/>
                 </a:solidFill>
@@ -7331,7 +7331,7 @@
               </a:defRPr>
             </a:pPr>
             <a:r>
-              <a:t>81-90%</a:t>
+              <a:t>81%</a:t>
             </a:r>
           </a:p>
         </p:txBody>
@@ -7475,7 +7475,7 @@
               </a:defRPr>
             </a:pPr>
             <a:r>
-              <a:t>CV pure 81% / CV+QD 90%</a:t>
+              <a:t>Level A 63% / Level B以上 81%</a:t>
             </a:r>
           </a:p>
         </p:txBody>
@@ -7511,7 +7511,7 @@
               </a:defRPr>
             </a:pPr>
             <a:r>
-              <a:t>CV不成立時は DV-FBQC 方式 (28kg / 2.1kW / 約6,480万円)</a:t>
+              <a:t>CV不成立時は DV-FBQC 方式 (本体28kg+冷却23kg / 2.1kW / 約6,480万円)</a:t>
             </a:r>
             <a:br/>
             <a:r>
@@ -8362,7 +8362,7 @@
             <a:pPr algn="ctr">
               <a:defRPr sz="900" b="0">
                 <a:solidFill>
-                  <a:srgbClr val="B0BEC5"/>
+                  <a:srgbClr val="FFFFFF"/>
                 </a:solidFill>
                 <a:latin typeface="Meiryo"/>
               </a:defRPr>
@@ -8434,7 +8434,7 @@
             <a:pPr algn="ctr">
               <a:defRPr sz="900" b="0">
                 <a:solidFill>
-                  <a:srgbClr val="B0BEC5"/>
+                  <a:srgbClr val="FFFFFF"/>
                 </a:solidFill>
                 <a:latin typeface="Meiryo"/>
               </a:defRPr>
@@ -10224,7 +10224,7 @@
               </a:defRPr>
             </a:pPr>
             <a:r>
-              <a:t>投資論理: 失敗時上限 4.6億円 (Phase -1)、成功時 ARR 36億円 (Y4) — リスク調整後リターン ~3.5倍</a:t>
+              <a:t>投資論理: 段階投資で失敗損失を限定 (最大 4.6億円)。成功時 Y4 ARR 36億円 / 総開発費 8.7億円</a:t>
             </a:r>
           </a:p>
         </p:txBody>
@@ -13567,7 +13567,7 @@
             <a:avLst/>
           </a:prstGeom>
           <a:solidFill>
-            <a:srgbClr val="66BB6A"/>
+            <a:srgbClr val="2E7D32"/>
           </a:solidFill>
           <a:ln>
             <a:noFill/>
@@ -13844,7 +13844,7 @@
             <a:avLst/>
           </a:prstGeom>
           <a:solidFill>
-            <a:srgbClr val="66BB6A"/>
+            <a:srgbClr val="2E7D32"/>
           </a:solidFill>
           <a:ln>
             <a:noFill/>
@@ -14121,7 +14121,7 @@
             <a:avLst/>
           </a:prstGeom>
           <a:solidFill>
-            <a:srgbClr val="66BB6A"/>
+            <a:srgbClr val="2E7D32"/>
           </a:solidFill>
           <a:ln>
             <a:noFill/>
@@ -14398,7 +14398,7 @@
             <a:avLst/>
           </a:prstGeom>
           <a:solidFill>
-            <a:srgbClr val="66BB6A"/>
+            <a:srgbClr val="2E7D32"/>
           </a:solidFill>
           <a:ln>
             <a:noFill/>
@@ -14675,7 +14675,7 @@
             <a:avLst/>
           </a:prstGeom>
           <a:solidFill>
-            <a:srgbClr val="66BB6A"/>
+            <a:srgbClr val="2E7D32"/>
           </a:solidFill>
           <a:ln>
             <a:noFill/>
@@ -14948,7 +14948,7 @@
             <a:avLst/>
           </a:prstGeom>
           <a:solidFill>
-            <a:srgbClr val="66BB6A"/>
+            <a:srgbClr val="2E7D32"/>
           </a:solidFill>
           <a:ln>
             <a:noFill/>
@@ -17777,7 +17777,7 @@
               </a:defRPr>
             </a:pPr>
             <a:r>
-              <a:t>Soft-info MWPM 閾値確立</a:t>
+              <a:t>Soft-info MWPM 閾値報告</a:t>
             </a:r>
           </a:p>
         </p:txBody>
@@ -17813,7 +17813,7 @@
               </a:defRPr>
             </a:pPr>
             <a:r>
-              <a:t>Noh-Chamberland 2022 で1.5%確定</a:t>
+              <a:t>Noh-Chamberland 2022 で p_th≈1.5%</a:t>
             </a:r>
           </a:p>
         </p:txBody>
@@ -20428,7 +20428,7 @@
           <a:lstStyle/>
           <a:p>
             <a:pPr algn="ctr">
-              <a:defRPr sz="900" b="0">
+              <a:defRPr sz="1000" b="0">
                 <a:solidFill>
                   <a:srgbClr val="757575"/>
                 </a:solidFill>
@@ -20583,7 +20583,7 @@
           <a:lstStyle/>
           <a:p>
             <a:pPr algn="ctr">
-              <a:defRPr sz="900" b="0">
+              <a:defRPr sz="1000" b="0">
                 <a:solidFill>
                   <a:srgbClr val="757575"/>
                 </a:solidFill>
@@ -20738,7 +20738,7 @@
           <a:lstStyle/>
           <a:p>
             <a:pPr algn="ctr">
-              <a:defRPr sz="900" b="0">
+              <a:defRPr sz="1000" b="0">
                 <a:solidFill>
                   <a:srgbClr val="757575"/>
                 </a:solidFill>
@@ -20893,7 +20893,7 @@
           <a:lstStyle/>
           <a:p>
             <a:pPr algn="ctr">
-              <a:defRPr sz="900" b="0">
+              <a:defRPr sz="1000" b="0">
                 <a:solidFill>
                   <a:srgbClr val="757575"/>
                 </a:solidFill>
@@ -21048,7 +21048,7 @@
           <a:lstStyle/>
           <a:p>
             <a:pPr algn="ctr">
-              <a:defRPr sz="900" b="0">
+              <a:defRPr sz="1000" b="0">
                 <a:solidFill>
                   <a:srgbClr val="FFFFFF"/>
                 </a:solidFill>
@@ -21116,7 +21116,7 @@
             <a:avLst/>
           </a:prstGeom>
           <a:solidFill>
-            <a:srgbClr val="66BB6A"/>
+            <a:srgbClr val="2E7D32"/>
           </a:solidFill>
           <a:ln>
             <a:noFill/>
@@ -23084,7 +23084,7 @@
             <a:pPr algn="ctr">
               <a:defRPr sz="900" b="1">
                 <a:solidFill>
-                  <a:srgbClr val="FFFFFF"/>
+                  <a:srgbClr val="212121"/>
                 </a:solidFill>
                 <a:latin typeface="Meiryo"/>
               </a:defRPr>

</xml_diff>

<commit_message>
fix(R11): 4-team review — 1 Critical + 4 Major + 4 Minor fixes across 7 slides
Critical:
- Slide 15: Remove unsubstantiated "10⁶×" QFT speedup → "理論的高速化"

Major:
- Slide 12: Donut label "FTQC実現確率" → "成功確率" (81% is Level B, not Level A)
- Slide 6: Add Δ+RIN caveat footnote (p_L 5-9×10⁻⁴ true range)
- Slide 16: Fix "他 8,300万" → "7,820万" (arithmetic: 3-line sum must = 4.6億)
- Slide 14: Y1/Y2 bar labels moved above short bars (下ずれ修正)

Minor:
- Slide 1: "TAROS" text box 1.5→1.8" (96pt font truncation prevention)
- Slide 16: "4.6億円" text box 0.8→1.0" (48pt font truncation prevention)
- Slide 14: ARR chart title add "(計画値)"
- Slide 14: Add Y1-Y4 timeline footnote (= 製品出荷後1-4年)

4-team findings: numerics-A (35 MATCH, 0 MISMATCH), numerics-B (2 HIGH layout),
logic (1C+6M+4m claims), ssot-deep (1 MISMATCH + 5 CONCERN cross-refs).

Co-Authored-By: Claude Opus 4.6 (1M context) <noreply@anthropic.com>
</commit_message>
<xml_diff>
--- a/assets/TAROS_Investor_Pitch_Revised.pptx
+++ b/assets/TAROS_Investor_Pitch_Revised.pptx
@@ -3164,7 +3164,7 @@
         <p:spPr>
           <a:xfrm>
             <a:off x="868680" y="731520"/>
-            <a:ext cx="9144000" cy="1371600"/>
+            <a:ext cx="9144000" cy="1645920"/>
           </a:xfrm>
           <a:prstGeom prst="rect">
             <a:avLst/>
@@ -7403,7 +7403,7 @@
               </a:defRPr>
             </a:pPr>
             <a:r>
-              <a:t>FTQC実現確率</a:t>
+              <a:t>成功確率</a:t>
             </a:r>
           </a:p>
         </p:txBody>
@@ -9541,7 +9541,7 @@
               </a:defRPr>
             </a:pPr>
             <a:r>
-              <a:t>A R R   成 長 予 測</a:t>
+              <a:t>A R R   成 長 予 測（計画値）</a:t>
             </a:r>
           </a:p>
         </p:txBody>
@@ -9597,7 +9597,7 @@
         </p:nvSpPr>
         <p:spPr>
           <a:xfrm>
-            <a:off x="4389120" y="4800600"/>
+            <a:off x="4389120" y="4389120"/>
             <a:ext cx="1463040" cy="365760"/>
           </a:xfrm>
           <a:prstGeom prst="rect">
@@ -10152,7 +10152,43 @@
       </p:sp>
       <p:sp>
         <p:nvSpPr>
-          <p:cNvPr id="33" name="Rectangle 32"/>
+          <p:cNvPr id="33" name="TextBox 32"/>
+          <p:cNvSpPr txBox="1"/>
+          <p:nvPr/>
+        </p:nvSpPr>
+        <p:spPr>
+          <a:xfrm>
+            <a:off x="4389120" y="5532120"/>
+            <a:ext cx="7315200" cy="228600"/>
+          </a:xfrm>
+          <a:prstGeom prst="rect">
+            <a:avLst/>
+          </a:prstGeom>
+          <a:noFill/>
+        </p:spPr>
+        <p:txBody>
+          <a:bodyPr wrap="square">
+            <a:spAutoFit/>
+          </a:bodyPr>
+          <a:lstStyle/>
+          <a:p>
+            <a:pPr algn="l">
+              <a:defRPr sz="900" b="0">
+                <a:solidFill>
+                  <a:srgbClr val="757575"/>
+                </a:solidFill>
+                <a:latin typeface="Meiryo"/>
+              </a:defRPr>
+            </a:pPr>
+            <a:r>
+              <a:t>※ Y1-Y4 = 製品出荷開始後1-4年（プロジェクト開始後約4-7年）</a:t>
+            </a:r>
+          </a:p>
+        </p:txBody>
+      </p:sp>
+      <p:sp>
+        <p:nvSpPr>
+          <p:cNvPr id="34" name="Rectangle 33"/>
           <p:cNvSpPr/>
           <p:nvPr/>
         </p:nvSpPr>
@@ -10195,7 +10231,7 @@
       </p:sp>
       <p:sp>
         <p:nvSpPr>
-          <p:cNvPr id="34" name="TextBox 33"/>
+          <p:cNvPr id="35" name="TextBox 34"/>
           <p:cNvSpPr txBox="1"/>
           <p:nvPr/>
         </p:nvSpPr>
@@ -11190,7 +11226,7 @@
               </a:defRPr>
             </a:pPr>
             <a:r>
-              <a:t>QFT: O(N×d³)→O(d³) 10⁶×高速化</a:t>
+              <a:t>QFT: O(N×d³)→O(d³) 理論的高速化</a:t>
             </a:r>
             <a:br/>
             <a:r>
@@ -11678,7 +11714,7 @@
         <p:spPr>
           <a:xfrm>
             <a:off x="731520" y="2286000"/>
-            <a:ext cx="3749039" cy="731520"/>
+            <a:ext cx="3749039" cy="914400"/>
           </a:xfrm>
           <a:prstGeom prst="rect">
             <a:avLst/>
@@ -12574,7 +12610,7 @@
               </a:defRPr>
             </a:pPr>
             <a:r>
-              <a:t>約 8,300万円</a:t>
+              <a:t>約 7,820万円</a:t>
             </a:r>
           </a:p>
         </p:txBody>
@@ -21354,7 +21390,7 @@
           <a:lstStyle/>
           <a:p>
             <a:pPr algn="l">
-              <a:defRPr sz="1200" b="0">
+              <a:defRPr sz="1100" b="0">
                 <a:solidFill>
                   <a:srgbClr val="212121"/>
                 </a:solidFill>
@@ -21362,7 +21398,7 @@
               </a:defRPr>
             </a:pPr>
             <a:r>
-              <a:t>→ Phase 2+ PIC 余裕 +1.8dB — 製品要件 p_L ≈ 3.3×10⁻⁴ を達成</a:t>
+              <a:t>→ Phase 2+ PIC 余裕 +1.8dB — 製品要件 p_L ≈ 3.3×10⁻⁴ を達成 †Δ・RIN込み推定 5-9×10⁻⁴, Phase -1で確定</a:t>
             </a:r>
           </a:p>
         </p:txBody>

</xml_diff>

<commit_message>
fix(R11b): Slide 14 Y1-Y4 timeline disclosure — 4-year runway now visible
- Bar labels: Y1→出荷Y1 (clarify these are post-shipment years, not post-investment)
- Chart title: add "出荷開始後1〜4年" context
- Footnote: "※出荷Y1 = 開始後約4年目（Phase -1〜1 完了後）"
- Prevents investor misread of Y1 revenue as Year 1 post-investment

Co-Authored-By: Claude Opus 4.6 (1M context) <noreply@anthropic.com>
</commit_message>
<xml_diff>
--- a/assets/TAROS_Investor_Pitch_Revised.pptx
+++ b/assets/TAROS_Investor_Pitch_Revised.pptx
@@ -9541,14 +9541,50 @@
               </a:defRPr>
             </a:pPr>
             <a:r>
-              <a:t>A R R   成 長 予 測（計画値）</a:t>
-            </a:r>
-          </a:p>
-        </p:txBody>
-      </p:sp>
-      <p:sp>
-        <p:nvSpPr>
-          <p:cNvPr id="17" name="Rectangle 16"/>
+              <a:t>A R R   成 長 予 測（計画値・出荷開始後1〜4年）</a:t>
+            </a:r>
+          </a:p>
+        </p:txBody>
+      </p:sp>
+      <p:sp>
+        <p:nvSpPr>
+          <p:cNvPr id="17" name="TextBox 16"/>
+          <p:cNvSpPr txBox="1"/>
+          <p:nvPr/>
+        </p:nvSpPr>
+        <p:spPr>
+          <a:xfrm>
+            <a:off x="4389120" y="1920240"/>
+            <a:ext cx="7315200" cy="228600"/>
+          </a:xfrm>
+          <a:prstGeom prst="rect">
+            <a:avLst/>
+          </a:prstGeom>
+          <a:noFill/>
+        </p:spPr>
+        <p:txBody>
+          <a:bodyPr wrap="square">
+            <a:spAutoFit/>
+          </a:bodyPr>
+          <a:lstStyle/>
+          <a:p>
+            <a:pPr algn="l">
+              <a:defRPr sz="900" b="0">
+                <a:solidFill>
+                  <a:srgbClr val="757575"/>
+                </a:solidFill>
+                <a:latin typeface="Meiryo"/>
+              </a:defRPr>
+            </a:pPr>
+            <a:r>
+              <a:t>※出荷Y1 = 開始後約4年目（Phase -1〜1 完了後）</a:t>
+            </a:r>
+          </a:p>
+        </p:txBody>
+      </p:sp>
+      <p:sp>
+        <p:nvSpPr>
+          <p:cNvPr id="18" name="Rectangle 17"/>
           <p:cNvSpPr/>
           <p:nvPr/>
         </p:nvSpPr>
@@ -9591,7 +9627,7 @@
       </p:sp>
       <p:sp>
         <p:nvSpPr>
-          <p:cNvPr id="18" name="TextBox 17"/>
+          <p:cNvPr id="19" name="TextBox 18"/>
           <p:cNvSpPr txBox="1"/>
           <p:nvPr/>
         </p:nvSpPr>
@@ -9627,7 +9663,7 @@
       </p:sp>
       <p:sp>
         <p:nvSpPr>
-          <p:cNvPr id="19" name="TextBox 18"/>
+          <p:cNvPr id="20" name="TextBox 19"/>
           <p:cNvSpPr txBox="1"/>
           <p:nvPr/>
         </p:nvSpPr>
@@ -9656,14 +9692,14 @@
               </a:defRPr>
             </a:pPr>
             <a:r>
-              <a:t>Y1</a:t>
-            </a:r>
-          </a:p>
-        </p:txBody>
-      </p:sp>
-      <p:sp>
-        <p:nvSpPr>
-          <p:cNvPr id="20" name="TextBox 19"/>
+              <a:t>出荷Y1</a:t>
+            </a:r>
+          </a:p>
+        </p:txBody>
+      </p:sp>
+      <p:sp>
+        <p:nvSpPr>
+          <p:cNvPr id="21" name="TextBox 20"/>
           <p:cNvSpPr txBox="1"/>
           <p:nvPr/>
         </p:nvSpPr>
@@ -9699,7 +9735,7 @@
       </p:sp>
       <p:sp>
         <p:nvSpPr>
-          <p:cNvPr id="21" name="Rectangle 20"/>
+          <p:cNvPr id="22" name="Rectangle 21"/>
           <p:cNvSpPr/>
           <p:nvPr/>
         </p:nvSpPr>
@@ -9742,7 +9778,7 @@
       </p:sp>
       <p:sp>
         <p:nvSpPr>
-          <p:cNvPr id="22" name="TextBox 21"/>
+          <p:cNvPr id="23" name="TextBox 22"/>
           <p:cNvSpPr txBox="1"/>
           <p:nvPr/>
         </p:nvSpPr>
@@ -9778,7 +9814,7 @@
       </p:sp>
       <p:sp>
         <p:nvSpPr>
-          <p:cNvPr id="23" name="TextBox 22"/>
+          <p:cNvPr id="24" name="TextBox 23"/>
           <p:cNvSpPr txBox="1"/>
           <p:nvPr/>
         </p:nvSpPr>
@@ -9807,14 +9843,14 @@
               </a:defRPr>
             </a:pPr>
             <a:r>
-              <a:t>Y2</a:t>
-            </a:r>
-          </a:p>
-        </p:txBody>
-      </p:sp>
-      <p:sp>
-        <p:nvSpPr>
-          <p:cNvPr id="24" name="TextBox 23"/>
+              <a:t>出荷Y2</a:t>
+            </a:r>
+          </a:p>
+        </p:txBody>
+      </p:sp>
+      <p:sp>
+        <p:nvSpPr>
+          <p:cNvPr id="25" name="TextBox 24"/>
           <p:cNvSpPr txBox="1"/>
           <p:nvPr/>
         </p:nvSpPr>
@@ -9850,7 +9886,7 @@
       </p:sp>
       <p:sp>
         <p:nvSpPr>
-          <p:cNvPr id="25" name="Rectangle 24"/>
+          <p:cNvPr id="26" name="Rectangle 25"/>
           <p:cNvSpPr/>
           <p:nvPr/>
         </p:nvSpPr>
@@ -9893,7 +9929,7 @@
       </p:sp>
       <p:sp>
         <p:nvSpPr>
-          <p:cNvPr id="26" name="TextBox 25"/>
+          <p:cNvPr id="27" name="TextBox 26"/>
           <p:cNvSpPr txBox="1"/>
           <p:nvPr/>
         </p:nvSpPr>
@@ -9929,7 +9965,7 @@
       </p:sp>
       <p:sp>
         <p:nvSpPr>
-          <p:cNvPr id="27" name="TextBox 26"/>
+          <p:cNvPr id="28" name="TextBox 27"/>
           <p:cNvSpPr txBox="1"/>
           <p:nvPr/>
         </p:nvSpPr>
@@ -9958,14 +9994,14 @@
               </a:defRPr>
             </a:pPr>
             <a:r>
-              <a:t>Y3</a:t>
-            </a:r>
-          </a:p>
-        </p:txBody>
-      </p:sp>
-      <p:sp>
-        <p:nvSpPr>
-          <p:cNvPr id="28" name="TextBox 27"/>
+              <a:t>出荷Y3</a:t>
+            </a:r>
+          </a:p>
+        </p:txBody>
+      </p:sp>
+      <p:sp>
+        <p:nvSpPr>
+          <p:cNvPr id="29" name="TextBox 28"/>
           <p:cNvSpPr txBox="1"/>
           <p:nvPr/>
         </p:nvSpPr>
@@ -10001,7 +10037,7 @@
       </p:sp>
       <p:sp>
         <p:nvSpPr>
-          <p:cNvPr id="29" name="Rectangle 28"/>
+          <p:cNvPr id="30" name="Rectangle 29"/>
           <p:cNvSpPr/>
           <p:nvPr/>
         </p:nvSpPr>
@@ -10044,7 +10080,7 @@
       </p:sp>
       <p:sp>
         <p:nvSpPr>
-          <p:cNvPr id="30" name="TextBox 29"/>
+          <p:cNvPr id="31" name="TextBox 30"/>
           <p:cNvSpPr txBox="1"/>
           <p:nvPr/>
         </p:nvSpPr>
@@ -10080,7 +10116,7 @@
       </p:sp>
       <p:sp>
         <p:nvSpPr>
-          <p:cNvPr id="31" name="TextBox 30"/>
+          <p:cNvPr id="32" name="TextBox 31"/>
           <p:cNvSpPr txBox="1"/>
           <p:nvPr/>
         </p:nvSpPr>
@@ -10109,14 +10145,14 @@
               </a:defRPr>
             </a:pPr>
             <a:r>
-              <a:t>Y4</a:t>
-            </a:r>
-          </a:p>
-        </p:txBody>
-      </p:sp>
-      <p:sp>
-        <p:nvSpPr>
-          <p:cNvPr id="32" name="TextBox 31"/>
+              <a:t>出荷Y4</a:t>
+            </a:r>
+          </a:p>
+        </p:txBody>
+      </p:sp>
+      <p:sp>
+        <p:nvSpPr>
+          <p:cNvPr id="33" name="TextBox 32"/>
           <p:cNvSpPr txBox="1"/>
           <p:nvPr/>
         </p:nvSpPr>
@@ -10152,7 +10188,7 @@
       </p:sp>
       <p:sp>
         <p:nvSpPr>
-          <p:cNvPr id="33" name="TextBox 32"/>
+          <p:cNvPr id="34" name="TextBox 33"/>
           <p:cNvSpPr txBox="1"/>
           <p:nvPr/>
         </p:nvSpPr>
@@ -10188,7 +10224,7 @@
       </p:sp>
       <p:sp>
         <p:nvSpPr>
-          <p:cNvPr id="34" name="Rectangle 33"/>
+          <p:cNvPr id="35" name="Rectangle 34"/>
           <p:cNvSpPr/>
           <p:nvPr/>
         </p:nvSpPr>
@@ -10231,7 +10267,7 @@
       </p:sp>
       <p:sp>
         <p:nvSpPr>
-          <p:cNvPr id="35" name="TextBox 34"/>
+          <p:cNvPr id="36" name="TextBox 35"/>
           <p:cNvSpPr txBox="1"/>
           <p:nvPr/>
         </p:nvSpPr>

</xml_diff>

<commit_message>
fix(R13): 4-team review — code cleanup + SSOT fix + layout polish
Code cleanup (edge team):
- Remove unused Emu import
- Remove dead add_para function
- Simplify Inches(0.04).inches → 0.04

SSOT fix (final team):
- development-cost-summary.md: Y4 gross profit 14.4億→11.7億
  (was using ~40% margin, corrected to SSOT 32.5%)
- Y2 gross profit 3億→2.9億 (32.5% precision)

Layout fix (render team):
- Slide 14: Remove redundant footnote (overlapped unit count labels;
  information already in chart title "計画値・出荷開始後1〜4年")

R13 findings (no code changes needed):
- devil: No team slide is #1 investor objection (user decision required)
- final: All 8 SSOT checks MATCH
- render: All R11/R12 fixes render correctly, no truncation
- edge: All boundary checks pass, no regressions

Co-Authored-By: Claude Opus 4.6 (1M context) <noreply@anthropic.com>
</commit_message>
<xml_diff>
--- a/assets/TAROS_Investor_Pitch_Revised.pptx
+++ b/assets/TAROS_Investor_Pitch_Revised.pptx
@@ -10152,43 +10152,7 @@
       </p:sp>
       <p:sp>
         <p:nvSpPr>
-          <p:cNvPr id="33" name="TextBox 32"/>
-          <p:cNvSpPr txBox="1"/>
-          <p:nvPr/>
-        </p:nvSpPr>
-        <p:spPr>
-          <a:xfrm>
-            <a:off x="4389120" y="5349240"/>
-            <a:ext cx="7315200" cy="228600"/>
-          </a:xfrm>
-          <a:prstGeom prst="rect">
-            <a:avLst/>
-          </a:prstGeom>
-          <a:noFill/>
-        </p:spPr>
-        <p:txBody>
-          <a:bodyPr wrap="square">
-            <a:spAutoFit/>
-          </a:bodyPr>
-          <a:lstStyle/>
-          <a:p>
-            <a:pPr algn="l">
-              <a:defRPr sz="900" b="0">
-                <a:solidFill>
-                  <a:srgbClr val="757575"/>
-                </a:solidFill>
-                <a:latin typeface="Meiryo"/>
-              </a:defRPr>
-            </a:pPr>
-            <a:r>
-              <a:t>※ Y1-Y4 = 製品出荷開始後1-4年（プロジェクト開始後約4-7年）</a:t>
-            </a:r>
-          </a:p>
-        </p:txBody>
-      </p:sp>
-      <p:sp>
-        <p:nvSpPr>
-          <p:cNvPr id="34" name="Rectangle 33"/>
+          <p:cNvPr id="33" name="Rectangle 32"/>
           <p:cNvSpPr/>
           <p:nvPr/>
         </p:nvSpPr>
@@ -10231,7 +10195,7 @@
       </p:sp>
       <p:sp>
         <p:nvSpPr>
-          <p:cNvPr id="35" name="TextBox 34"/>
+          <p:cNvPr id="34" name="TextBox 33"/>
           <p:cNvSpPr txBox="1"/>
           <p:nvPr/>
         </p:nvSpPr>

</xml_diff>